<commit_message>
resolve bug with requests and update documentation
</commit_message>
<xml_diff>
--- a/presentation/rest-graphql-grpc-ai-routing-v4.pptx
+++ b/presentation/rest-graphql-grpc-ai-routing-v4.pptx
@@ -155,13 +155,13 @@
 
 <file path=ppt/comments/modernComment_100_6CC67404.xml><?xml version="1.0" encoding="utf-8"?>
 <p188:cmLst xmlns:a="http://schemas.openxmlformats.org/drawingml/2006/main" xmlns:r="http://schemas.openxmlformats.org/officeDocument/2006/relationships" xmlns:p188="http://schemas.microsoft.com/office/powerpoint/2018/8/main">
-  <p188:cm id="{F5ACA150-C8BD-7B46-9E67-4EBAED79B357}" authorId="{30C35E52-AC13-A436-6686-0B6764E2623F}" created="2026-10-08T20:12:06.434">
+  <p188:cm id="{F5ACA150-C8BD-7B46-9E67-4EBAED79B357}" authorId="{30C35E52-AC13-A436-6686-0B6764E2623F}" status="resolved" created="2026-10-08T20:12:06.434" complete="100000">
     <ac:txMkLst xmlns:ac="http://schemas.microsoft.com/office/drawing/2013/main/command">
       <pc:docMk xmlns:pc="http://schemas.microsoft.com/office/powerpoint/2013/main/command"/>
       <pc:sldMk xmlns:pc="http://schemas.microsoft.com/office/powerpoint/2013/main/command" cId="1824945156" sldId="256"/>
       <ac:spMk id="10" creationId="{09A5BA9F-BF66-4223-8B7A-531B9F168E56}"/>
-      <ac:txMk cp="0" len="18">
-        <ac:context len="37" hash="3423938112"/>
+      <ac:txMk cp="0">
+        <ac:context len="28" hash="1267279807"/>
       </ac:txMk>
     </ac:txMkLst>
     <p188:pos x="1371600" y="228600"/>
@@ -176,13 +176,13 @@
       </a:p>
     </p188:txBody>
   </p188:cm>
-  <p188:cm id="{0061D9EC-F51B-B04E-AC67-97A9480DED29}" authorId="{30C35E52-AC13-A436-6686-0B6764E2623F}" created="2026-10-08T20:12:47.781">
+  <p188:cm id="{0061D9EC-F51B-B04E-AC67-97A9480DED29}" authorId="{30C35E52-AC13-A436-6686-0B6764E2623F}" status="resolved" created="2026-10-08T20:12:47.781" complete="100000">
     <ac:txMkLst xmlns:ac="http://schemas.microsoft.com/office/drawing/2013/main/command">
       <pc:docMk xmlns:pc="http://schemas.microsoft.com/office/powerpoint/2013/main/command"/>
       <pc:sldMk xmlns:pc="http://schemas.microsoft.com/office/powerpoint/2013/main/command" cId="1824945156" sldId="256"/>
       <ac:spMk id="9" creationId="{51C42803-AD44-41C4-9AB0-5DA8E6196539}"/>
-      <ac:txMk cp="0" len="12">
-        <ac:context len="208" hash="3738785220"/>
+      <ac:txMk cp="0" len="26">
+        <ac:context len="222" hash="4139588301"/>
       </ac:txMk>
     </ac:txMkLst>
     <p188:pos x="901700" y="228600"/>
@@ -501,6 +501,13 @@
           </p:nvPr>
         </p:nvSpPr>
         <p:spPr/>
+        <p:txBody>
+          <a:bodyPr/>
+          <a:lstStyle/>
+          <a:p>
+            <a:endParaRPr lang="en-US"/>
+          </a:p>
+        </p:txBody>
       </p:sp>
       <p:sp>
         <p:nvSpPr>
@@ -518,85 +525,121 @@
           <a:lstStyle/>
           <a:p>
             <a:r>
+              <a:rPr dirty="0"/>
               <a:t>SAY:</a:t>
             </a:r>
-            <a:br/>
-            <a:endParaRPr/>
-          </a:p>
-          <a:p>
-            <a:r>
+            <a:br>
+              <a:rPr dirty="0"/>
+            </a:br>
+            <a:endParaRPr dirty="0"/>
+          </a:p>
+          <a:p>
+            <a:r>
+              <a:rPr dirty="0"/>
               <a:t>"Thank you all for being here. There is a lot on the agenda today, and we do not take your time lightly."</a:t>
             </a:r>
-            <a:br/>
-            <a:endParaRPr/>
-          </a:p>
-          <a:p>
-            <a:br/>
-            <a:endParaRPr/>
-          </a:p>
-          <a:p>
-            <a:r>
+            <a:br>
+              <a:rPr dirty="0"/>
+            </a:br>
+            <a:endParaRPr dirty="0"/>
+          </a:p>
+          <a:p>
+            <a:br>
+              <a:rPr dirty="0"/>
+            </a:br>
+            <a:endParaRPr dirty="0"/>
+          </a:p>
+          <a:p>
+            <a:r>
+              <a:rPr dirty="0"/>
               <a:t>"This is a 300-level session on REST, GraphQL and gRPC. Not a beginner overview, and not a vendor pitch."</a:t>
             </a:r>
-            <a:br/>
-            <a:endParaRPr/>
-          </a:p>
-          <a:p>
-            <a:br/>
-            <a:endParaRPr/>
-          </a:p>
-          <a:p>
-            <a:r>
+            <a:br>
+              <a:rPr dirty="0"/>
+            </a:br>
+            <a:endParaRPr dirty="0"/>
+          </a:p>
+          <a:p>
+            <a:br>
+              <a:rPr dirty="0"/>
+            </a:br>
+            <a:endParaRPr dirty="0"/>
+          </a:p>
+          <a:p>
+            <a:r>
+              <a:rPr dirty="0"/>
               <a:t>1. "We will look at where each protocol fits and where it strains."</a:t>
             </a:r>
-            <a:br/>
-            <a:endParaRPr/>
-          </a:p>
-          <a:p>
-            <a:r>
+            <a:br>
+              <a:rPr dirty="0"/>
+            </a:br>
+            <a:endParaRPr dirty="0"/>
+          </a:p>
+          <a:p>
+            <a:r>
+              <a:rPr dirty="0"/>
               <a:t>2. "We will show all three running side by side in one application — real traffic, nothing mocked."</a:t>
             </a:r>
-            <a:br/>
-            <a:endParaRPr/>
-          </a:p>
-          <a:p>
-            <a:r>
+            <a:br>
+              <a:rPr dirty="0"/>
+            </a:br>
+            <a:endParaRPr dirty="0"/>
+          </a:p>
+          <a:p>
+            <a:r>
+              <a:rPr dirty="0"/>
               <a:t>3. "And we will share what we have seen in the field, with clients who had to make this choice for real."</a:t>
             </a:r>
-            <a:br/>
-            <a:endParaRPr/>
-          </a:p>
-          <a:p>
-            <a:br/>
-            <a:endParaRPr/>
-          </a:p>
-          <a:p>
-            <a:r>
+            <a:br>
+              <a:rPr dirty="0"/>
+            </a:br>
+            <a:endParaRPr dirty="0"/>
+          </a:p>
+          <a:p>
+            <a:br>
+              <a:rPr dirty="0"/>
+            </a:br>
+            <a:endParaRPr dirty="0"/>
+          </a:p>
+          <a:p>
+            <a:r>
+              <a:rPr dirty="0"/>
               <a:t>BE CLEAR ABOUT THIS:</a:t>
             </a:r>
-            <a:br/>
-            <a:endParaRPr/>
-          </a:p>
-          <a:p>
-            <a:r>
+            <a:br>
+              <a:rPr dirty="0"/>
+            </a:br>
+            <a:endParaRPr dirty="0"/>
+          </a:p>
+          <a:p>
+            <a:r>
+              <a:rPr dirty="0"/>
               <a:t>"There is no winner in this talk. The goal is to leave you with a way to choose, not a protocol to adopt."</a:t>
             </a:r>
-            <a:br/>
-            <a:endParaRPr/>
-          </a:p>
-          <a:p>
-            <a:br/>
-            <a:endParaRPr/>
-          </a:p>
-          <a:p>
-            <a:r>
+            <a:br>
+              <a:rPr dirty="0"/>
+            </a:br>
+            <a:endParaRPr dirty="0"/>
+          </a:p>
+          <a:p>
+            <a:br>
+              <a:rPr dirty="0"/>
+            </a:br>
+            <a:endParaRPr dirty="0"/>
+          </a:p>
+          <a:p>
+            <a:r>
+              <a:rPr dirty="0"/>
               <a:t>TRANSITION:</a:t>
             </a:r>
-            <a:br/>
-            <a:endParaRPr/>
-          </a:p>
-          <a:p>
-            <a:r>
+            <a:br>
+              <a:rPr dirty="0"/>
+            </a:br>
+            <a:endParaRPr dirty="0"/>
+          </a:p>
+          <a:p>
+            <a:r>
+              <a:rPr dirty="0"/>
               <a:t>"Let me show you how the session is laid out."</a:t>
             </a:r>
           </a:p>
@@ -657,6 +700,13 @@
           </p:nvPr>
         </p:nvSpPr>
         <p:spPr/>
+        <p:txBody>
+          <a:bodyPr/>
+          <a:lstStyle/>
+          <a:p>
+            <a:endParaRPr lang="en-US"/>
+          </a:p>
+        </p:txBody>
       </p:sp>
       <p:sp>
         <p:nvSpPr>
@@ -795,6 +845,13 @@
           </p:nvPr>
         </p:nvSpPr>
         <p:spPr/>
+        <p:txBody>
+          <a:bodyPr/>
+          <a:lstStyle/>
+          <a:p>
+            <a:endParaRPr lang="en-US"/>
+          </a:p>
+        </p:txBody>
       </p:sp>
       <p:sp>
         <p:nvSpPr>
@@ -812,94 +869,182 @@
           <a:lstStyle/>
           <a:p>
             <a:r>
+              <a:rPr dirty="0"/>
               <a:t>SAY:</a:t>
             </a:r>
           </a:p>
           <a:p>
-            <a:endParaRPr/>
-          </a:p>
-          <a:p>
-            <a:r>
+            <a:endParaRPr dirty="0"/>
+          </a:p>
+          <a:p>
+            <a:r>
+              <a:rPr dirty="0"/>
               <a:t>"Relationship questions go to GraphQL."</a:t>
             </a:r>
           </a:p>
           <a:p>
-            <a:endParaRPr/>
-          </a:p>
-          <a:p>
-            <a:r>
-              <a:t>1. "This shortened ExploreStarships query connects the Falcon to its films, character cast and explicit flight crew. The full application query also requests numeric fields, IDs, source URLs and top-level films."</a:t>
-            </a:r>
-          </a:p>
-          <a:p>
-            <a:r>
+            <a:endParaRPr dirty="0"/>
+          </a:p>
+          <a:p>
+            <a:r>
+              <a:rPr dirty="0"/>
+              <a:t>1. "This shortened </a:t>
+            </a:r>
+            <a:r>
+              <a:rPr dirty="0" err="1"/>
+              <a:t>ExploreStarships</a:t>
+            </a:r>
+            <a:r>
+              <a:rPr dirty="0"/>
+              <a:t> query connects the Falcon to its films, character cast and explicit flight crew. The full application query also requests numeric fields, IDs, source URLs and top-level films."</a:t>
+            </a:r>
+          </a:p>
+          <a:p>
+            <a:r>
+              <a:rPr dirty="0"/>
               <a:t>2. "The target crew:5:1 means ship 5, the Millennium Falcon, in film 1, A New Hope."</a:t>
             </a:r>
           </a:p>
           <a:p>
             <a:r>
+              <a:rPr dirty="0"/>
               <a:t>3. "The response names Han Solo as pilot and Chewbacca as co-pilot. Luke and Leia appear in the film cast, but that does not make them Falcon pilots."</a:t>
             </a:r>
           </a:p>
           <a:p>
-            <a:endParaRPr/>
-          </a:p>
-          <a:p>
-            <a:r>
+            <a:endParaRPr dirty="0"/>
+          </a:p>
+          <a:p>
+            <a:r>
+              <a:rPr dirty="0"/>
               <a:t>BE CLEAR ABOUT THIS:</a:t>
             </a:r>
           </a:p>
           <a:p>
-            <a:endParaRPr/>
-          </a:p>
-          <a:p>
-            <a:r>
+            <a:endParaRPr dirty="0"/>
+          </a:p>
+          <a:p>
+            <a:r>
+              <a:rPr dirty="0"/>
               <a:t>"The film is part of the relationship. The Battle of Endor records in Return of the Jedi instead name Lando Calrissian and Nien Nunb. These are documented assignments in a partial demo catalog, not a complete flight history."</a:t>
             </a:r>
           </a:p>
           <a:p>
-            <a:endParaRPr/>
-          </a:p>
-          <a:p>
-            <a:r>
+            <a:endParaRPr dirty="0"/>
+          </a:p>
+          <a:p>
+            <a:r>
+              <a:rPr dirty="0"/>
               <a:t>TRANSITION:</a:t>
             </a:r>
           </a:p>
           <a:p>
-            <a:endParaRPr/>
-          </a:p>
-          <a:p>
-            <a:r>
+            <a:endParaRPr dirty="0"/>
+          </a:p>
+          <a:p>
+            <a:r>
+              <a:rPr dirty="0"/>
               <a:t>"Now we will look at gRPC streaming."</a:t>
             </a:r>
           </a:p>
           <a:p>
-            <a:endParaRPr/>
-          </a:p>
-          <a:p>
-            <a:r>
+            <a:endParaRPr dirty="0"/>
+          </a:p>
+          <a:p>
+            <a:r>
+              <a:rPr dirty="0"/>
               <a:t>SOURCES:</a:t>
             </a:r>
           </a:p>
           <a:p>
             <a:r>
-              <a:t>Project: backend/src/main/resources/graphql/schema.graphqls and backend/src/main/resources/catalog.json.</a:t>
-            </a:r>
-          </a:p>
-          <a:p>
-            <a:r>
-              <a:t>https://www.starwars.com/databank/han-solo</a:t>
-            </a:r>
-          </a:p>
-          <a:p>
-            <a:r>
-              <a:t>https://www.starwars.com/databank/chewbacca</a:t>
-            </a:r>
-          </a:p>
-          <a:p>
-            <a:r>
-              <a:t>https://www.starwars.com/databank/nien-nunb</a:t>
-            </a:r>
+              <a:rPr dirty="0"/>
+              <a:t>Project: backend/src/main/resources/</a:t>
+            </a:r>
+            <a:r>
+              <a:rPr dirty="0" err="1"/>
+              <a:t>graphql</a:t>
+            </a:r>
+            <a:r>
+              <a:rPr dirty="0"/>
+              <a:t>/</a:t>
+            </a:r>
+            <a:r>
+              <a:rPr dirty="0" err="1"/>
+              <a:t>schema.graphqls</a:t>
+            </a:r>
+            <a:r>
+              <a:rPr dirty="0"/>
+              <a:t> and backend/src/main/resources/</a:t>
+            </a:r>
+            <a:r>
+              <a:rPr dirty="0" err="1"/>
+              <a:t>catalog.json</a:t>
+            </a:r>
+            <a:r>
+              <a:rPr dirty="0"/>
+              <a:t>.</a:t>
+            </a:r>
+          </a:p>
+          <a:p>
+            <a:r>
+              <a:rPr dirty="0"/>
+              <a:t>https://</a:t>
+            </a:r>
+            <a:r>
+              <a:rPr dirty="0" err="1"/>
+              <a:t>www.starwars.com</a:t>
+            </a:r>
+            <a:r>
+              <a:rPr dirty="0"/>
+              <a:t>/databank/</a:t>
+            </a:r>
+            <a:r>
+              <a:rPr dirty="0" err="1"/>
+              <a:t>han</a:t>
+            </a:r>
+            <a:r>
+              <a:rPr dirty="0"/>
+              <a:t>-solo</a:t>
+            </a:r>
+          </a:p>
+          <a:p>
+            <a:r>
+              <a:rPr dirty="0"/>
+              <a:t>https://</a:t>
+            </a:r>
+            <a:r>
+              <a:rPr dirty="0" err="1"/>
+              <a:t>www.starwars.com</a:t>
+            </a:r>
+            <a:r>
+              <a:rPr dirty="0"/>
+              <a:t>/databank/</a:t>
+            </a:r>
+            <a:r>
+              <a:rPr dirty="0" err="1"/>
+              <a:t>chewbacca</a:t>
+            </a:r>
+            <a:endParaRPr dirty="0"/>
+          </a:p>
+          <a:p>
+            <a:r>
+              <a:rPr dirty="0"/>
+              <a:t>https://</a:t>
+            </a:r>
+            <a:r>
+              <a:rPr dirty="0" err="1"/>
+              <a:t>www.starwars.com</a:t>
+            </a:r>
+            <a:r>
+              <a:rPr dirty="0"/>
+              <a:t>/databank/</a:t>
+            </a:r>
+            <a:r>
+              <a:rPr dirty="0" err="1"/>
+              <a:t>nien-nunb</a:t>
+            </a:r>
+            <a:endParaRPr dirty="0"/>
           </a:p>
         </p:txBody>
       </p:sp>
@@ -958,6 +1103,13 @@
           </p:nvPr>
         </p:nvSpPr>
         <p:spPr/>
+        <p:txBody>
+          <a:bodyPr/>
+          <a:lstStyle/>
+          <a:p>
+            <a:endParaRPr lang="en-US"/>
+          </a:p>
+        </p:txBody>
       </p:sp>
       <p:sp>
         <p:nvSpPr>
@@ -975,67 +1127,103 @@
           <a:lstStyle/>
           <a:p>
             <a:r>
+              <a:rPr dirty="0"/>
               <a:t>SAY:</a:t>
             </a:r>
-            <a:br/>
-            <a:endParaRPr/>
-          </a:p>
-          <a:p>
-            <a:r>
-              <a:t>"gRPC is contract-first RPC over HTTP/2, with compact binary Protobuf messages."</a:t>
-            </a:r>
-            <a:br/>
-            <a:endParaRPr/>
-          </a:p>
-          <a:p>
-            <a:br/>
-            <a:endParaRPr/>
-          </a:p>
-          <a:p>
-            <a:r>
+            <a:br>
+              <a:rPr dirty="0"/>
+            </a:br>
+            <a:endParaRPr dirty="0"/>
+          </a:p>
+          <a:p>
+            <a:r>
+              <a:rPr dirty="0"/>
+              <a:t>"gRPC is contract-first RPC over HTTP/2, with compact binary </a:t>
+            </a:r>
+            <a:r>
+              <a:rPr dirty="0" err="1"/>
+              <a:t>Protobuf</a:t>
+            </a:r>
+            <a:r>
+              <a:rPr dirty="0"/>
+              <a:t> messages."</a:t>
+            </a:r>
+            <a:br>
+              <a:rPr dirty="0"/>
+            </a:br>
+            <a:endParaRPr dirty="0"/>
+          </a:p>
+          <a:p>
+            <a:br>
+              <a:rPr dirty="0"/>
+            </a:br>
+            <a:endParaRPr dirty="0"/>
+          </a:p>
+          <a:p>
+            <a:r>
+              <a:rPr dirty="0"/>
               <a:t>1. "Where it shines: generated clients from one proto file in many languages, HTTP/2 multiplexing, four call types including bidirectional streaming, and deadlines and cancellation built in."</a:t>
             </a:r>
-            <a:br/>
-            <a:endParaRPr/>
-          </a:p>
-          <a:p>
-            <a:r>
+            <a:br>
+              <a:rPr dirty="0"/>
+            </a:br>
+            <a:endParaRPr dirty="0"/>
+          </a:p>
+          <a:p>
+            <a:r>
+              <a:rPr dirty="0"/>
               <a:t>2. "Where it strains: browsers need gRPC-Web or a bridge, binary payloads are harder to debug, you need HTTP/2 end to end through every proxy, and field numbers are forever."</a:t>
             </a:r>
-            <a:br/>
-            <a:endParaRPr/>
-          </a:p>
-          <a:p>
-            <a:br/>
-            <a:endParaRPr/>
-          </a:p>
-          <a:p>
-            <a:r>
+            <a:br>
+              <a:rPr dirty="0"/>
+            </a:br>
+            <a:endParaRPr dirty="0"/>
+          </a:p>
+          <a:p>
+            <a:br>
+              <a:rPr dirty="0"/>
+            </a:br>
+            <a:endParaRPr dirty="0"/>
+          </a:p>
+          <a:p>
+            <a:r>
+              <a:rPr dirty="0"/>
               <a:t>BE CLEAR ABOUT THIS:</a:t>
             </a:r>
-            <a:br/>
-            <a:endParaRPr/>
-          </a:p>
-          <a:p>
-            <a:r>
+            <a:br>
+              <a:rPr dirty="0"/>
+            </a:br>
+            <a:endParaRPr dirty="0"/>
+          </a:p>
+          <a:p>
+            <a:r>
+              <a:rPr dirty="0"/>
               <a:t>"gRPC is the right tool for internal service-to-service calls, low-latency paths and real-time streams — not usually for your public API."</a:t>
             </a:r>
-            <a:br/>
-            <a:endParaRPr/>
-          </a:p>
-          <a:p>
-            <a:br/>
-            <a:endParaRPr/>
-          </a:p>
-          <a:p>
-            <a:r>
+            <a:br>
+              <a:rPr dirty="0"/>
+            </a:br>
+            <a:endParaRPr dirty="0"/>
+          </a:p>
+          <a:p>
+            <a:br>
+              <a:rPr dirty="0"/>
+            </a:br>
+            <a:endParaRPr dirty="0"/>
+          </a:p>
+          <a:p>
+            <a:r>
+              <a:rPr dirty="0"/>
               <a:t>TRANSITION:</a:t>
             </a:r>
-            <a:br/>
-            <a:endParaRPr/>
-          </a:p>
-          <a:p>
-            <a:r>
+            <a:br>
+              <a:rPr dirty="0"/>
+            </a:br>
+            <a:endParaRPr dirty="0"/>
+          </a:p>
+          <a:p>
+            <a:r>
+              <a:rPr dirty="0"/>
               <a:t>"Here is the contract behind the demo's streaming feature."</a:t>
             </a:r>
           </a:p>
@@ -1096,6 +1284,13 @@
           </p:nvPr>
         </p:nvSpPr>
         <p:spPr/>
+        <p:txBody>
+          <a:bodyPr/>
+          <a:lstStyle/>
+          <a:p>
+            <a:endParaRPr lang="en-US"/>
+          </a:p>
+        </p:txBody>
       </p:sp>
       <p:sp>
         <p:nvSpPr>
@@ -1113,102 +1308,180 @@
           <a:lstStyle/>
           <a:p>
             <a:r>
+              <a:rPr dirty="0"/>
               <a:t>SAY:</a:t>
             </a:r>
           </a:p>
           <a:p>
-            <a:endParaRPr/>
-          </a:p>
-          <a:p>
-            <a:r>
+            <a:endParaRPr dirty="0"/>
+          </a:p>
+          <a:p>
+            <a:r>
+              <a:rPr dirty="0"/>
               <a:t>"Ask once, and the ship's location, pilot and shields change in the chat as updates arrive."</a:t>
             </a:r>
           </a:p>
           <a:p>
-            <a:endParaRPr/>
-          </a:p>
-          <a:p>
-            <a:r>
+            <a:endParaRPr dirty="0"/>
+          </a:p>
+          <a:p>
+            <a:r>
+              <a:rPr dirty="0"/>
               <a:t>"Watch is a real server-streaming gRPC call: one request and twenty-one responses over about forty seconds. The server owns the timeline, so the agent does not rerun the question or ask the model to route every update."</a:t>
             </a:r>
           </a:p>
           <a:p>
-            <a:endParaRPr/>
-          </a:p>
-          <a:p>
-            <a:r>
+            <a:endParaRPr dirty="0"/>
+          </a:p>
+          <a:p>
+            <a:r>
+              <a:rPr dirty="0"/>
               <a:t>"The browser receives each update through the NDJSON bridge. The backend explicitly flushes the servlet response after every event so updates arrive individually."</a:t>
             </a:r>
           </a:p>
           <a:p>
-            <a:endParaRPr/>
-          </a:p>
-          <a:p>
-            <a:r>
+            <a:endParaRPr dirty="0"/>
+          </a:p>
+          <a:p>
+            <a:r>
+              <a:rPr dirty="0"/>
               <a:t>DEMONSTRATE:</a:t>
             </a:r>
           </a:p>
           <a:p>
-            <a:endParaRPr/>
-          </a:p>
-          <a:p>
-            <a:r>
+            <a:endParaRPr dirty="0"/>
+          </a:p>
+          <a:p>
+            <a:r>
+              <a:rPr dirty="0"/>
               <a:t>Click Present flight. The Falcon departs Tatooine, Chewbacca takes the controls, a debris alert lowers shields, Han retakes the controls, and the ship travels through hyperspace to Yavin 4. The UI keeps the final state and flight log; Stop keeps the last received state, and Replay starts again.</a:t>
             </a:r>
           </a:p>
           <a:p>
-            <a:endParaRPr/>
-          </a:p>
-          <a:p>
-            <a:r>
+            <a:endParaRPr dirty="0"/>
+          </a:p>
+          <a:p>
+            <a:r>
+              <a:rPr dirty="0"/>
               <a:t>BE CLEAR ABOUT THIS:</a:t>
             </a:r>
           </a:p>
           <a:p>
-            <a:endParaRPr/>
-          </a:p>
-          <a:p>
-            <a:r>
+            <a:endParaRPr dirty="0"/>
+          </a:p>
+          <a:p>
+            <a:r>
+              <a:rPr dirty="0"/>
               <a:t>This is authored fiction for a repeatable presentation, not canon flight history or live telemetry. The script is separate from documented film-crew records. Only the Falcon has a flight scenario; other targets return catalog data with an explicit coverage message. Each subscription starts its own timeline.</a:t>
             </a:r>
           </a:p>
           <a:p>
-            <a:endParaRPr/>
-          </a:p>
-          <a:p>
-            <a:r>
-              <a:t>The older bidirectional Track method remains available for comparison. Bidirectional streaming is useful when a client must change its request during an open response stream; this guided flight only needs server streaming. The displayed proto is an excerpt; FlightState and other fields are omitted for space.</a:t>
-            </a:r>
-          </a:p>
-          <a:p>
-            <a:endParaRPr/>
-          </a:p>
-          <a:p>
-            <a:r>
-              <a:t>Default pacing is 2000 ms for 40 seconds. DEMO_FLIGHT_INTERVAL_MS=3000 gives 60 seconds; 5000 gives 100 seconds. Restart the backend after changing it. The gRPC deadline is 115 seconds; response sizes count serialized Protobuf bytes, not headers or framing. Playback time is not a protocol speed benchmark.</a:t>
-            </a:r>
-          </a:p>
-          <a:p>
-            <a:endParaRPr/>
-          </a:p>
-          <a:p>
-            <a:r>
+            <a:endParaRPr dirty="0"/>
+          </a:p>
+          <a:p>
+            <a:r>
+              <a:rPr dirty="0"/>
+              <a:t>The older bidirectional Track method remains available for comparison. Bidirectional streaming is useful when a client must change its request during an open response stream; this guided flight only needs server streaming. The displayed proto is an excerpt; </a:t>
+            </a:r>
+            <a:r>
+              <a:rPr dirty="0" err="1"/>
+              <a:t>FlightState</a:t>
+            </a:r>
+            <a:r>
+              <a:rPr dirty="0"/>
+              <a:t> and other fields are omitted for space.</a:t>
+            </a:r>
+          </a:p>
+          <a:p>
+            <a:endParaRPr dirty="0"/>
+          </a:p>
+          <a:p>
+            <a:r>
+              <a:rPr dirty="0"/>
+              <a:t>Default pacing is 2000 </a:t>
+            </a:r>
+            <a:r>
+              <a:rPr dirty="0" err="1"/>
+              <a:t>ms</a:t>
+            </a:r>
+            <a:r>
+              <a:rPr dirty="0"/>
+              <a:t> for 40 seconds. DEMO_FLIGHT_INTERVAL_MS=3000 gives 60 seconds; 5000 gives 100 seconds. Restart the backend after changing it. The gRPC deadline is 115 seconds; response sizes count serialized </a:t>
+            </a:r>
+            <a:r>
+              <a:rPr dirty="0" err="1"/>
+              <a:t>Protobuf</a:t>
+            </a:r>
+            <a:r>
+              <a:rPr dirty="0"/>
+              <a:t> bytes, not headers or framing. Playback time is not a protocol speed benchmark.</a:t>
+            </a:r>
+          </a:p>
+          <a:p>
+            <a:endParaRPr dirty="0"/>
+          </a:p>
+          <a:p>
+            <a:r>
+              <a:rPr dirty="0"/>
               <a:t>SOURCES:</a:t>
             </a:r>
           </a:p>
           <a:p>
             <a:r>
-              <a:t>Project: backend/src/main/proto/catalog.proto, backend/src/main/resources/falcon-flight.json, docs/architecture.md.</a:t>
-            </a:r>
-          </a:p>
-          <a:p>
-            <a:r>
-              <a:t>https://grpc.io/docs/languages/java/generated-code/</a:t>
-            </a:r>
-          </a:p>
-          <a:p>
-            <a:r>
-              <a:t>https://grpc.io/docs/guides/cancellation/</a:t>
+              <a:rPr dirty="0"/>
+              <a:t>Project: backend/src/main/proto/</a:t>
+            </a:r>
+            <a:r>
+              <a:rPr dirty="0" err="1"/>
+              <a:t>catalog.proto</a:t>
+            </a:r>
+            <a:r>
+              <a:rPr dirty="0"/>
+              <a:t>, backend/src/main/resources/falcon-</a:t>
+            </a:r>
+            <a:r>
+              <a:rPr dirty="0" err="1"/>
+              <a:t>flight.json</a:t>
+            </a:r>
+            <a:r>
+              <a:rPr dirty="0"/>
+              <a:t>, docs/</a:t>
+            </a:r>
+            <a:r>
+              <a:rPr dirty="0" err="1"/>
+              <a:t>architecture.md</a:t>
+            </a:r>
+            <a:r>
+              <a:rPr dirty="0"/>
+              <a:t>.</a:t>
+            </a:r>
+          </a:p>
+          <a:p>
+            <a:r>
+              <a:rPr dirty="0"/>
+              <a:t>https://</a:t>
+            </a:r>
+            <a:r>
+              <a:rPr dirty="0" err="1"/>
+              <a:t>grpc.io</a:t>
+            </a:r>
+            <a:r>
+              <a:rPr dirty="0"/>
+              <a:t>/docs/languages/java/generated-code/</a:t>
+            </a:r>
+          </a:p>
+          <a:p>
+            <a:r>
+              <a:rPr dirty="0"/>
+              <a:t>https://</a:t>
+            </a:r>
+            <a:r>
+              <a:rPr dirty="0" err="1"/>
+              <a:t>grpc.io</a:t>
+            </a:r>
+            <a:r>
+              <a:rPr dirty="0"/>
+              <a:t>/docs/guides/cancellation/</a:t>
             </a:r>
           </a:p>
         </p:txBody>
@@ -1268,6 +1541,13 @@
           </p:nvPr>
         </p:nvSpPr>
         <p:spPr/>
+        <p:txBody>
+          <a:bodyPr/>
+          <a:lstStyle/>
+          <a:p>
+            <a:endParaRPr lang="en-US"/>
+          </a:p>
+        </p:txBody>
       </p:sp>
       <p:sp>
         <p:nvSpPr>
@@ -1285,67 +1565,103 @@
           <a:lstStyle/>
           <a:p>
             <a:r>
+              <a:rPr dirty="0"/>
               <a:t>SAY:</a:t>
             </a:r>
-            <a:br/>
-            <a:endParaRPr/>
-          </a:p>
-          <a:p>
-            <a:r>
+            <a:br>
+              <a:rPr dirty="0"/>
+            </a:br>
+            <a:endParaRPr dirty="0"/>
+          </a:p>
+          <a:p>
+            <a:r>
+              <a:rPr dirty="0"/>
               <a:t>"Each of these answered the problem of its moment."</a:t>
             </a:r>
-            <a:br/>
-            <a:endParaRPr/>
-          </a:p>
-          <a:p>
-            <a:br/>
-            <a:endParaRPr/>
-          </a:p>
-          <a:p>
-            <a:r>
+            <a:br>
+              <a:rPr dirty="0"/>
+            </a:br>
+            <a:endParaRPr dirty="0"/>
+          </a:p>
+          <a:p>
+            <a:br>
+              <a:rPr dirty="0"/>
+            </a:br>
+            <a:endParaRPr dirty="0"/>
+          </a:p>
+          <a:p>
+            <a:r>
+              <a:rPr dirty="0"/>
               <a:t>1. "REST was described in Roy Fielding's dissertation in 2000."</a:t>
             </a:r>
-            <a:br/>
-            <a:endParaRPr/>
-          </a:p>
-          <a:p>
-            <a:r>
+            <a:br>
+              <a:rPr dirty="0"/>
+            </a:br>
+            <a:endParaRPr dirty="0"/>
+          </a:p>
+          <a:p>
+            <a:r>
+              <a:rPr dirty="0"/>
               <a:t>2. "GraphQL was built inside Facebook in 2012 for mobile, and published as a spec in 2015."</a:t>
             </a:r>
-            <a:br/>
-            <a:endParaRPr/>
-          </a:p>
-          <a:p>
-            <a:r>
+            <a:br>
+              <a:rPr dirty="0"/>
+            </a:br>
+            <a:endParaRPr dirty="0"/>
+          </a:p>
+          <a:p>
+            <a:r>
+              <a:rPr dirty="0"/>
               <a:t>3. "gRPC was open-sourced by Google in 2015, reached 1.0 in 2016, and joined the CNCF in 2017."</a:t>
             </a:r>
-            <a:br/>
-            <a:endParaRPr/>
-          </a:p>
-          <a:p>
-            <a:br/>
-            <a:endParaRPr/>
-          </a:p>
-          <a:p>
-            <a:r>
-              <a:t>"On the practical side: REST has the lowest learning curve and the largest ecosystem. GraphQL and gRPC are both mature, and gRPC's learning curve is mostly the toolchain rather than the concepts."</a:t>
-            </a:r>
-            <a:br/>
-            <a:endParaRPr/>
-          </a:p>
-          <a:p>
-            <a:br/>
-            <a:endParaRPr/>
-          </a:p>
-          <a:p>
-            <a:r>
+            <a:br>
+              <a:rPr dirty="0"/>
+            </a:br>
+            <a:endParaRPr dirty="0"/>
+          </a:p>
+          <a:p>
+            <a:br>
+              <a:rPr dirty="0"/>
+            </a:br>
+            <a:endParaRPr dirty="0"/>
+          </a:p>
+          <a:p>
+            <a:r>
+              <a:rPr dirty="0"/>
+              <a:t>"On the practical side: REST has the lowest learning curve and the largest ecosystem. GraphQL and gRPC are both mature, and </a:t>
+            </a:r>
+            <a:r>
+              <a:rPr dirty="0" err="1"/>
+              <a:t>gRPC's</a:t>
+            </a:r>
+            <a:r>
+              <a:rPr dirty="0"/>
+              <a:t> learning curve is mostly the toolchain rather than the concepts."</a:t>
+            </a:r>
+            <a:br>
+              <a:rPr dirty="0"/>
+            </a:br>
+            <a:endParaRPr dirty="0"/>
+          </a:p>
+          <a:p>
+            <a:br>
+              <a:rPr dirty="0"/>
+            </a:br>
+            <a:endParaRPr dirty="0"/>
+          </a:p>
+          <a:p>
+            <a:r>
+              <a:rPr dirty="0"/>
               <a:t>TRANSITION:</a:t>
             </a:r>
-            <a:br/>
-            <a:endParaRPr/>
-          </a:p>
-          <a:p>
-            <a:r>
+            <a:br>
+              <a:rPr dirty="0"/>
+            </a:br>
+            <a:endParaRPr dirty="0"/>
+          </a:p>
+          <a:p>
+            <a:r>
+              <a:rPr dirty="0"/>
               <a:t>"Enough slides. Let's look at it running."</a:t>
             </a:r>
           </a:p>
@@ -1406,6 +1722,13 @@
           </p:nvPr>
         </p:nvSpPr>
         <p:spPr/>
+        <p:txBody>
+          <a:bodyPr/>
+          <a:lstStyle/>
+          <a:p>
+            <a:endParaRPr lang="en-US"/>
+          </a:p>
+        </p:txBody>
       </p:sp>
       <p:sp>
         <p:nvSpPr>
@@ -1508,6 +1831,13 @@
           </p:nvPr>
         </p:nvSpPr>
         <p:spPr/>
+        <p:txBody>
+          <a:bodyPr/>
+          <a:lstStyle/>
+          <a:p>
+            <a:endParaRPr lang="en-US"/>
+          </a:p>
+        </p:txBody>
       </p:sp>
       <p:sp>
         <p:nvSpPr>
@@ -1525,134 +1855,206 @@
           <a:lstStyle/>
           <a:p>
             <a:r>
+              <a:rPr dirty="0"/>
               <a:t>SAY:</a:t>
             </a:r>
           </a:p>
           <a:p>
-            <a:endParaRPr/>
-          </a:p>
-          <a:p>
-            <a:r>
+            <a:endParaRPr dirty="0"/>
+          </a:p>
+          <a:p>
+            <a:r>
+              <a:rPr dirty="0"/>
               <a:t>"This is Protocol Studio. Ask a question, see the selected protocol and its explanation, and inspect the real request and response."</a:t>
             </a:r>
           </a:p>
           <a:p>
-            <a:endParaRPr/>
-          </a:p>
-          <a:p>
-            <a:r>
+            <a:endParaRPr dirty="0"/>
+          </a:p>
+          <a:p>
+            <a:r>
+              <a:rPr dirty="0"/>
               <a:t>DO:</a:t>
             </a:r>
           </a:p>
           <a:p>
-            <a:endParaRPr/>
-          </a:p>
-          <a:p>
-            <a:r>
+            <a:endParaRPr dirty="0"/>
+          </a:p>
+          <a:p>
+            <a:r>
+              <a:rPr dirty="0"/>
               <a:t>1. Ask "Tell me about the Millennium Falcon." Show REST, the cache header and the response size.</a:t>
             </a:r>
           </a:p>
           <a:p>
             <a:r>
+              <a:rPr dirty="0"/>
               <a:t>2. Ask "Who flew the Millennium Falcon in A New Hope?" Show GraphQL, the 'Why this protocol' explanation, and target crew:5:1. The answer names Han Solo and Chewbacca.</a:t>
             </a:r>
           </a:p>
           <a:p>
             <a:r>
+              <a:rPr dirty="0"/>
               <a:t>3. Ask "Track the Millennium Falcon." Click Present flight and watch location, pilot, shields and flight events update over about forty seconds. Point out the Chewbacca handoff, alert, recovery and arrival. Close the presentation view and inspect one Watch request with twenty-one responses.</a:t>
             </a:r>
           </a:p>
           <a:p>
-            <a:endParaRPr/>
-          </a:p>
-          <a:p>
-            <a:r>
+            <a:endParaRPr dirty="0"/>
+          </a:p>
+          <a:p>
+            <a:r>
+              <a:rPr dirty="0"/>
               <a:t>OPTIONAL FOLLOW-UPS:</a:t>
             </a:r>
           </a:p>
           <a:p>
-            <a:endParaRPr/>
-          </a:p>
-          <a:p>
-            <a:r>
+            <a:endParaRPr dirty="0"/>
+          </a:p>
+          <a:p>
+            <a:r>
+              <a:rPr dirty="0"/>
               <a:t>"Where is the Millennium Falcon currently?" and "Who is currently flying the Millennium Falcon?" also start the labeled flight simulation. Each new request starts its own replay, not a shared continuously running galaxy.</a:t>
             </a:r>
           </a:p>
           <a:p>
-            <a:endParaRPr/>
-          </a:p>
-          <a:p>
-            <a:r>
+            <a:endParaRPr dirty="0"/>
+          </a:p>
+          <a:p>
+            <a:r>
+              <a:rPr dirty="0"/>
               <a:t>"Which films feature Luke Skywalker?" explores character appearances.</a:t>
             </a:r>
           </a:p>
           <a:p>
             <a:r>
+              <a:rPr dirty="0"/>
               <a:t>"Who flew the Millennium Falcon in Return of the Jedi?" returns Lando Calrissian and Nien Nunb for the Battle of Endor.</a:t>
             </a:r>
           </a:p>
           <a:p>
-            <a:endParaRPr/>
-          </a:p>
-          <a:p>
-            <a:r>
+            <a:endParaRPr dirty="0"/>
+          </a:p>
+          <a:p>
+            <a:r>
+              <a:rPr dirty="0"/>
               <a:t>BE CLEAR ABOUT THIS:</a:t>
             </a:r>
           </a:p>
           <a:p>
-            <a:endParaRPr/>
-          </a:p>
-          <a:p>
-            <a:r>
+            <a:endParaRPr dirty="0"/>
+          </a:p>
+          <a:p>
+            <a:r>
+              <a:rPr dirty="0"/>
               <a:t>"Cast means fictional characters. Flight-crew data is film-specific and partial. The gRPC flight is a clearly labeled fictional simulation, separate from documented film crew. It is repeatable, not a canon itinerary or live telemetry."</a:t>
             </a:r>
           </a:p>
           <a:p>
-            <a:endParaRPr/>
-          </a:p>
-          <a:p>
-            <a:r>
+            <a:endParaRPr dirty="0"/>
+          </a:p>
+          <a:p>
+            <a:r>
+              <a:rPr dirty="0"/>
               <a:t>"A presenter override applies to one question and the UI labels it. Allow the local model to warm up before presenting."</a:t>
             </a:r>
           </a:p>
           <a:p>
-            <a:endParaRPr/>
-          </a:p>
-          <a:p>
-            <a:r>
+            <a:endParaRPr dirty="0"/>
+          </a:p>
+          <a:p>
+            <a:r>
+              <a:rPr dirty="0"/>
               <a:t>TRANSITION:</a:t>
             </a:r>
           </a:p>
           <a:p>
-            <a:endParaRPr/>
-          </a:p>
-          <a:p>
-            <a:r>
+            <a:endParaRPr dirty="0"/>
+          </a:p>
+          <a:p>
+            <a:r>
+              <a:rPr dirty="0"/>
               <a:t>"That is the lab example. Here is what this looks like with real clients."</a:t>
             </a:r>
           </a:p>
           <a:p>
-            <a:endParaRPr/>
-          </a:p>
-          <a:p>
-            <a:r>
+            <a:endParaRPr dirty="0"/>
+          </a:p>
+          <a:p>
+            <a:r>
+              <a:rPr dirty="0"/>
               <a:t>SOURCES:</a:t>
             </a:r>
           </a:p>
           <a:p>
             <a:r>
-              <a:t>Project: docs/dataset-provenance.md, docs/validation.md and backend/src/main/resources/catalog.json.</a:t>
-            </a:r>
-          </a:p>
-          <a:p>
-            <a:r>
-              <a:t>https://www.starwars.com/databank/han-solo</a:t>
-            </a:r>
-          </a:p>
-          <a:p>
-            <a:r>
-              <a:t>https://www.starwars.com/databank/chewbacca</a:t>
-            </a:r>
+              <a:rPr dirty="0"/>
+              <a:t>Project: docs/dataset-</a:t>
+            </a:r>
+            <a:r>
+              <a:rPr dirty="0" err="1"/>
+              <a:t>provenance.md</a:t>
+            </a:r>
+            <a:r>
+              <a:rPr dirty="0"/>
+              <a:t>, docs/</a:t>
+            </a:r>
+            <a:r>
+              <a:rPr dirty="0" err="1"/>
+              <a:t>validation.md</a:t>
+            </a:r>
+            <a:r>
+              <a:rPr dirty="0"/>
+              <a:t> and backend/src/main/resources/</a:t>
+            </a:r>
+            <a:r>
+              <a:rPr dirty="0" err="1"/>
+              <a:t>catalog.json</a:t>
+            </a:r>
+            <a:r>
+              <a:rPr dirty="0"/>
+              <a:t>.</a:t>
+            </a:r>
+          </a:p>
+          <a:p>
+            <a:r>
+              <a:rPr dirty="0"/>
+              <a:t>https://</a:t>
+            </a:r>
+            <a:r>
+              <a:rPr dirty="0" err="1"/>
+              <a:t>www.starwars.com</a:t>
+            </a:r>
+            <a:r>
+              <a:rPr dirty="0"/>
+              <a:t>/databank/</a:t>
+            </a:r>
+            <a:r>
+              <a:rPr dirty="0" err="1"/>
+              <a:t>han</a:t>
+            </a:r>
+            <a:r>
+              <a:rPr dirty="0"/>
+              <a:t>-solo</a:t>
+            </a:r>
+          </a:p>
+          <a:p>
+            <a:r>
+              <a:rPr dirty="0"/>
+              <a:t>https://</a:t>
+            </a:r>
+            <a:r>
+              <a:rPr dirty="0" err="1"/>
+              <a:t>www.starwars.com</a:t>
+            </a:r>
+            <a:r>
+              <a:rPr dirty="0"/>
+              <a:t>/databank/</a:t>
+            </a:r>
+            <a:r>
+              <a:rPr dirty="0" err="1"/>
+              <a:t>chewbacca</a:t>
+            </a:r>
+            <a:endParaRPr dirty="0"/>
           </a:p>
         </p:txBody>
       </p:sp>
@@ -1711,6 +2113,13 @@
           </p:nvPr>
         </p:nvSpPr>
         <p:spPr/>
+        <p:txBody>
+          <a:bodyPr/>
+          <a:lstStyle/>
+          <a:p>
+            <a:endParaRPr lang="en-US"/>
+          </a:p>
+        </p:txBody>
       </p:sp>
       <p:sp>
         <p:nvSpPr>
@@ -1856,6 +2265,13 @@
           </p:nvPr>
         </p:nvSpPr>
         <p:spPr/>
+        <p:txBody>
+          <a:bodyPr/>
+          <a:lstStyle/>
+          <a:p>
+            <a:endParaRPr lang="en-US"/>
+          </a:p>
+        </p:txBody>
       </p:sp>
       <p:sp>
         <p:nvSpPr>
@@ -1873,74 +2289,105 @@
           <a:lstStyle/>
           <a:p>
             <a:r>
+              <a:rPr dirty="0"/>
               <a:t>SAY:</a:t>
             </a:r>
-            <a:br/>
-            <a:endParaRPr/>
-          </a:p>
-          <a:p>
-            <a:r>
+            <a:br>
+              <a:rPr dirty="0"/>
+            </a:br>
+            <a:endParaRPr dirty="0"/>
+          </a:p>
+          <a:p>
+            <a:r>
+              <a:rPr dirty="0"/>
               <a:t>"Our second client is a global retail coffee company, rebuilding point of sale and ordering."</a:t>
             </a:r>
-            <a:br/>
-            <a:endParaRPr/>
-          </a:p>
-          <a:p>
-            <a:br/>
-            <a:endParaRPr/>
-          </a:p>
-          <a:p>
-            <a:r>
+            <a:br>
+              <a:rPr dirty="0"/>
+            </a:br>
+            <a:endParaRPr dirty="0"/>
+          </a:p>
+          <a:p>
+            <a:br>
+              <a:rPr dirty="0"/>
+            </a:br>
+            <a:endParaRPr dirty="0"/>
+          </a:p>
+          <a:p>
+            <a:r>
+              <a:rPr dirty="0"/>
               <a:t>1. "Thirty-three thousand locations. Security and offline operation are non-negotiable."</a:t>
             </a:r>
-            <a:br/>
-            <a:endParaRPr/>
-          </a:p>
-          <a:p>
-            <a:r>
+            <a:br>
+              <a:rPr dirty="0"/>
+            </a:br>
+            <a:endParaRPr dirty="0"/>
+          </a:p>
+          <a:p>
+            <a:r>
+              <a:rPr dirty="0"/>
               <a:t>2. "They have limited ability to expose endpoints at the store."</a:t>
             </a:r>
-            <a:br/>
-            <a:endParaRPr/>
-          </a:p>
-          <a:p>
-            <a:r>
+            <a:br>
+              <a:rPr dirty="0"/>
+            </a:br>
+            <a:endParaRPr dirty="0"/>
+          </a:p>
+          <a:p>
+            <a:r>
+              <a:rPr dirty="0"/>
               <a:t>3. "gRPC integration reduced that exposure and increased performance, with typed contracts between services."</a:t>
             </a:r>
-            <a:br/>
-            <a:endParaRPr/>
-          </a:p>
-          <a:p>
-            <a:br/>
-            <a:endParaRPr/>
-          </a:p>
-          <a:p>
-            <a:r>
+            <a:br>
+              <a:rPr dirty="0"/>
+            </a:br>
+            <a:endParaRPr dirty="0"/>
+          </a:p>
+          <a:p>
+            <a:br>
+              <a:rPr dirty="0"/>
+            </a:br>
+            <a:endParaRPr dirty="0"/>
+          </a:p>
+          <a:p>
+            <a:r>
+              <a:rPr dirty="0"/>
               <a:t>BE CLEAR ABOUT THIS:</a:t>
             </a:r>
-            <a:br/>
-            <a:endParaRPr/>
-          </a:p>
-          <a:p>
-            <a:r>
+            <a:br>
+              <a:rPr dirty="0"/>
+            </a:br>
+            <a:endParaRPr dirty="0"/>
+          </a:p>
+          <a:p>
+            <a:r>
+              <a:rPr dirty="0"/>
               <a:t>"Same decision process, different answer. The constraints — exposure, offline, performance — pointed to gRPC."</a:t>
             </a:r>
-            <a:br/>
-            <a:endParaRPr/>
-          </a:p>
-          <a:p>
-            <a:br/>
-            <a:endParaRPr/>
-          </a:p>
-          <a:p>
-            <a:r>
+            <a:br>
+              <a:rPr dirty="0"/>
+            </a:br>
+            <a:endParaRPr dirty="0"/>
+          </a:p>
+          <a:p>
+            <a:br>
+              <a:rPr dirty="0"/>
+            </a:br>
+            <a:endParaRPr dirty="0"/>
+          </a:p>
+          <a:p>
+            <a:r>
+              <a:rPr dirty="0"/>
               <a:t>TRANSITION:</a:t>
             </a:r>
-            <a:br/>
-            <a:endParaRPr/>
-          </a:p>
-          <a:p>
-            <a:r>
+            <a:br>
+              <a:rPr dirty="0"/>
+            </a:br>
+            <a:endParaRPr dirty="0"/>
+          </a:p>
+          <a:p>
+            <a:r>
+              <a:rPr dirty="0"/>
               <a:t>"So what should you take away from all of this?"</a:t>
             </a:r>
           </a:p>
@@ -2001,6 +2448,13 @@
           </p:nvPr>
         </p:nvSpPr>
         <p:spPr/>
+        <p:txBody>
+          <a:bodyPr/>
+          <a:lstStyle/>
+          <a:p>
+            <a:endParaRPr lang="en-US"/>
+          </a:p>
+        </p:txBody>
       </p:sp>
       <p:sp>
         <p:nvSpPr>
@@ -2018,74 +2472,105 @@
           <a:lstStyle/>
           <a:p>
             <a:r>
+              <a:rPr dirty="0"/>
               <a:t>SAY:</a:t>
             </a:r>
-            <a:br/>
-            <a:endParaRPr/>
-          </a:p>
-          <a:p>
-            <a:r>
+            <a:br>
+              <a:rPr dirty="0"/>
+            </a:br>
+            <a:endParaRPr dirty="0"/>
+          </a:p>
+          <a:p>
+            <a:r>
+              <a:rPr dirty="0"/>
               <a:t>"Three things to take away."</a:t>
             </a:r>
-            <a:br/>
-            <a:endParaRPr/>
-          </a:p>
-          <a:p>
-            <a:br/>
-            <a:endParaRPr/>
-          </a:p>
-          <a:p>
-            <a:r>
+            <a:br>
+              <a:rPr dirty="0"/>
+            </a:br>
+            <a:endParaRPr dirty="0"/>
+          </a:p>
+          <a:p>
+            <a:br>
+              <a:rPr dirty="0"/>
+            </a:br>
+            <a:endParaRPr dirty="0"/>
+          </a:p>
+          <a:p>
+            <a:r>
+              <a:rPr dirty="0"/>
               <a:t>1. "Choose per operation. REST for cacheable resources, GraphQL for related data, gRPC for streams and service-to-service calls. Most systems use more than one."</a:t>
             </a:r>
-            <a:br/>
-            <a:endParaRPr/>
-          </a:p>
-          <a:p>
-            <a:r>
+            <a:br>
+              <a:rPr dirty="0"/>
+            </a:br>
+            <a:endParaRPr dirty="0"/>
+          </a:p>
+          <a:p>
+            <a:r>
+              <a:rPr dirty="0"/>
               <a:t>2. "Design the contract first. OpenAPI, schema or proto file — the contract outlives the implementation and drives your tooling, tests and code generation."</a:t>
             </a:r>
-            <a:br/>
-            <a:endParaRPr/>
-          </a:p>
-          <a:p>
-            <a:r>
+            <a:br>
+              <a:rPr dirty="0"/>
+            </a:br>
+            <a:endParaRPr dirty="0"/>
+          </a:p>
+          <a:p>
+            <a:r>
+              <a:rPr dirty="0"/>
               <a:t>3. "Measure the whole path. Round trips, payload size and caching decide real-world latency more than the protocol label does."</a:t>
             </a:r>
-            <a:br/>
-            <a:endParaRPr/>
-          </a:p>
-          <a:p>
-            <a:br/>
-            <a:endParaRPr/>
-          </a:p>
-          <a:p>
-            <a:r>
+            <a:br>
+              <a:rPr dirty="0"/>
+            </a:br>
+            <a:endParaRPr dirty="0"/>
+          </a:p>
+          <a:p>
+            <a:br>
+              <a:rPr dirty="0"/>
+            </a:br>
+            <a:endParaRPr dirty="0"/>
+          </a:p>
+          <a:p>
+            <a:r>
+              <a:rPr dirty="0"/>
               <a:t>BE CLEAR ABOUT THIS:</a:t>
             </a:r>
-            <a:br/>
-            <a:endParaRPr/>
-          </a:p>
-          <a:p>
-            <a:r>
+            <a:br>
+              <a:rPr dirty="0"/>
+            </a:br>
+            <a:endParaRPr dirty="0"/>
+          </a:p>
+          <a:p>
+            <a:r>
+              <a:rPr dirty="0"/>
               <a:t>"Everything you saw today is in the repository — the code, the runbook and the measurements — so you can run it yourself."</a:t>
             </a:r>
-            <a:br/>
-            <a:endParaRPr/>
-          </a:p>
-          <a:p>
-            <a:br/>
-            <a:endParaRPr/>
-          </a:p>
-          <a:p>
-            <a:r>
+            <a:br>
+              <a:rPr dirty="0"/>
+            </a:br>
+            <a:endParaRPr dirty="0"/>
+          </a:p>
+          <a:p>
+            <a:br>
+              <a:rPr dirty="0"/>
+            </a:br>
+            <a:endParaRPr dirty="0"/>
+          </a:p>
+          <a:p>
+            <a:r>
+              <a:rPr dirty="0"/>
               <a:t>TRANSITION:</a:t>
             </a:r>
-            <a:br/>
-            <a:endParaRPr/>
-          </a:p>
-          <a:p>
-            <a:r>
+            <a:br>
+              <a:rPr dirty="0"/>
+            </a:br>
+            <a:endParaRPr dirty="0"/>
+          </a:p>
+          <a:p>
+            <a:r>
+              <a:rPr dirty="0"/>
               <a:t>"With that, let's open it up."</a:t>
             </a:r>
           </a:p>
@@ -2146,6 +2631,13 @@
           </p:nvPr>
         </p:nvSpPr>
         <p:spPr/>
+        <p:txBody>
+          <a:bodyPr/>
+          <a:lstStyle/>
+          <a:p>
+            <a:endParaRPr lang="en-US"/>
+          </a:p>
+        </p:txBody>
       </p:sp>
       <p:sp>
         <p:nvSpPr>
@@ -2246,23 +2738,7 @@
           <a:p>
             <a:r>
               <a:rPr dirty="0"/>
-              <a:t>"Everything you see today runs. Every request in the demo is real HTTP, </a:t>
-            </a:r>
-            <a:r>
-              <a:rPr dirty="0" err="1"/>
-              <a:t>GraphQL</a:t>
-            </a:r>
-            <a:r>
-              <a:rPr dirty="0"/>
-              <a:t> or </a:t>
-            </a:r>
-            <a:r>
-              <a:rPr dirty="0" err="1"/>
-              <a:t>gRPC</a:t>
-            </a:r>
-            <a:r>
-              <a:rPr dirty="0"/>
-              <a:t> traffic you can inspect."</a:t>
+              <a:t>"Everything you see today runs. Every request in the demo is real HTTP, GraphQL or gRPC traffic you can inspect."</a:t>
             </a:r>
             <a:br>
               <a:rPr dirty="0"/>
@@ -2348,6 +2824,13 @@
           </p:nvPr>
         </p:nvSpPr>
         <p:spPr/>
+        <p:txBody>
+          <a:bodyPr/>
+          <a:lstStyle/>
+          <a:p>
+            <a:endParaRPr lang="en-US"/>
+          </a:p>
+        </p:txBody>
       </p:sp>
       <p:sp>
         <p:nvSpPr>
@@ -2472,6 +2955,13 @@
           </p:nvPr>
         </p:nvSpPr>
         <p:spPr/>
+        <p:txBody>
+          <a:bodyPr/>
+          <a:lstStyle/>
+          <a:p>
+            <a:endParaRPr lang="en-US"/>
+          </a:p>
+        </p:txBody>
       </p:sp>
       <p:sp>
         <p:nvSpPr>
@@ -2599,6 +3089,13 @@
           </p:nvPr>
         </p:nvSpPr>
         <p:spPr/>
+        <p:txBody>
+          <a:bodyPr/>
+          <a:lstStyle/>
+          <a:p>
+            <a:endParaRPr lang="en-US"/>
+          </a:p>
+        </p:txBody>
       </p:sp>
       <p:sp>
         <p:nvSpPr>
@@ -2616,89 +3113,142 @@
           <a:lstStyle/>
           <a:p>
             <a:r>
+              <a:rPr dirty="0"/>
               <a:t>SAY:</a:t>
             </a:r>
-            <a:br/>
-            <a:endParaRPr/>
-          </a:p>
-          <a:p>
-            <a:r>
+            <a:br>
+              <a:rPr dirty="0"/>
+            </a:br>
+            <a:endParaRPr dirty="0"/>
+          </a:p>
+          <a:p>
+            <a:r>
+              <a:rPr dirty="0"/>
               <a:t>"Every question goes through five steps."</a:t>
             </a:r>
-            <a:br/>
-            <a:endParaRPr/>
-          </a:p>
-          <a:p>
-            <a:br/>
-            <a:endParaRPr/>
-          </a:p>
-          <a:p>
-            <a:r>
+            <a:br>
+              <a:rPr dirty="0"/>
+            </a:br>
+            <a:endParaRPr dirty="0"/>
+          </a:p>
+          <a:p>
+            <a:br>
+              <a:rPr dirty="0"/>
+            </a:br>
+            <a:endParaRPr dirty="0"/>
+          </a:p>
+          <a:p>
+            <a:r>
+              <a:rPr dirty="0"/>
               <a:t>1. "The browser posts the message and recent turns."</a:t>
             </a:r>
-            <a:br/>
-            <a:endParaRPr/>
-          </a:p>
-          <a:p>
-            <a:r>
-              <a:t>2. "A classifier — Ollama or Jev, behind one interface — picks one protocol and one allowlisted target."</a:t>
-            </a:r>
-            <a:br/>
-            <a:endParaRPr/>
-          </a:p>
-          <a:p>
-            <a:r>
+            <a:br>
+              <a:rPr dirty="0"/>
+            </a:br>
+            <a:endParaRPr dirty="0"/>
+          </a:p>
+          <a:p>
+            <a:r>
+              <a:rPr dirty="0"/>
+              <a:t>2. "A classifier — Ollama or </a:t>
+            </a:r>
+            <a:r>
+              <a:rPr dirty="0" err="1"/>
+              <a:t>Jev</a:t>
+            </a:r>
+            <a:r>
+              <a:rPr dirty="0"/>
+              <a:t>, behind one interface — picks one protocol and one allowlisted target."</a:t>
+            </a:r>
+            <a:br>
+              <a:rPr dirty="0"/>
+            </a:br>
+            <a:endParaRPr dirty="0"/>
+          </a:p>
+          <a:p>
+            <a:r>
+              <a:rPr dirty="0"/>
               <a:t>3. "The decision is just protocol plus target. Never a URL, never query text."</a:t>
             </a:r>
-            <a:br/>
-            <a:endParaRPr/>
-          </a:p>
-          <a:p>
-            <a:r>
+            <a:br>
+              <a:rPr dirty="0"/>
+            </a:br>
+            <a:endParaRPr dirty="0"/>
+          </a:p>
+          <a:p>
+            <a:r>
+              <a:rPr dirty="0"/>
               <a:t>4. "The server calls its own REST, GraphQL or native gRPC endpoint — real traffic."</a:t>
             </a:r>
-            <a:br/>
-            <a:endParaRPr/>
-          </a:p>
-          <a:p>
-            <a:r>
+            <a:br>
+              <a:rPr dirty="0"/>
+            </a:br>
+            <a:endParaRPr dirty="0"/>
+          </a:p>
+          <a:p>
+            <a:r>
+              <a:rPr dirty="0"/>
               <a:t>5. "The answer is composed from the response, and the inspector shows the payloads and timings."</a:t>
             </a:r>
-            <a:br/>
-            <a:endParaRPr/>
-          </a:p>
-          <a:p>
-            <a:br/>
-            <a:endParaRPr/>
-          </a:p>
-          <a:p>
-            <a:r>
+            <a:br>
+              <a:rPr dirty="0"/>
+            </a:br>
+            <a:endParaRPr dirty="0"/>
+          </a:p>
+          <a:p>
+            <a:br>
+              <a:rPr dirty="0"/>
+            </a:br>
+            <a:endParaRPr dirty="0"/>
+          </a:p>
+          <a:p>
+            <a:r>
+              <a:rPr dirty="0"/>
               <a:t>BE CLEAR ABOUT THIS:</a:t>
             </a:r>
-            <a:br/>
-            <a:endParaRPr/>
-          </a:p>
-          <a:p>
-            <a:r>
+            <a:br>
+              <a:rPr dirty="0"/>
+            </a:br>
+            <a:endParaRPr dirty="0"/>
+          </a:p>
+          <a:p>
+            <a:r>
+              <a:rPr dirty="0"/>
               <a:t>"The model chooses the route. It never supplies the data. If it routes wrongly, you can see it — and it cannot invent facts."</a:t>
             </a:r>
-            <a:br/>
-            <a:endParaRPr/>
-          </a:p>
-          <a:p>
-            <a:br/>
-            <a:endParaRPr/>
-          </a:p>
-          <a:p>
-            <a:r>
+            <a:br>
+              <a:rPr dirty="0"/>
+            </a:br>
+            <a:endParaRPr dirty="0"/>
+          </a:p>
+          <a:p>
+            <a:br>
+              <a:rPr dirty="0"/>
+            </a:br>
+            <a:endParaRPr dirty="0"/>
+          </a:p>
+          <a:p>
+            <a:r>
+              <a:rPr dirty="0"/>
               <a:t>TRANSITION:</a:t>
             </a:r>
-            <a:br/>
-            <a:endParaRPr/>
-          </a:p>
-          <a:p>
-            <a:r>
-              <a:t>"Let's look at the default router: Ollama."</a:t>
+            <a:br>
+              <a:rPr dirty="0"/>
+            </a:br>
+            <a:endParaRPr dirty="0"/>
+          </a:p>
+          <a:p>
+            <a:r>
+              <a:rPr dirty="0"/>
+              <a:t>"Let's look at the default router: </a:t>
+            </a:r>
+            <a:r>
+              <a:rPr dirty="0" err="1"/>
+              <a:t>Ollama</a:t>
+            </a:r>
+            <a:r>
+              <a:rPr dirty="0"/>
+              <a:t>."</a:t>
             </a:r>
           </a:p>
         </p:txBody>
@@ -2758,6 +3308,13 @@
           </p:nvPr>
         </p:nvSpPr>
         <p:spPr/>
+        <p:txBody>
+          <a:bodyPr/>
+          <a:lstStyle/>
+          <a:p>
+            <a:endParaRPr lang="en-US"/>
+          </a:p>
+        </p:txBody>
       </p:sp>
       <p:sp>
         <p:nvSpPr>
@@ -2941,6 +3498,13 @@
           </p:nvPr>
         </p:nvSpPr>
         <p:spPr/>
+        <p:txBody>
+          <a:bodyPr/>
+          <a:lstStyle/>
+          <a:p>
+            <a:endParaRPr lang="en-US"/>
+          </a:p>
+        </p:txBody>
       </p:sp>
       <p:sp>
         <p:nvSpPr>
@@ -3093,6 +3657,13 @@
           </p:nvPr>
         </p:nvSpPr>
         <p:spPr/>
+        <p:txBody>
+          <a:bodyPr/>
+          <a:lstStyle/>
+          <a:p>
+            <a:endParaRPr lang="en-US"/>
+          </a:p>
+        </p:txBody>
       </p:sp>
       <p:sp>
         <p:nvSpPr>
@@ -3231,6 +3802,13 @@
           </p:nvPr>
         </p:nvSpPr>
         <p:spPr/>
+        <p:txBody>
+          <a:bodyPr/>
+          <a:lstStyle/>
+          <a:p>
+            <a:endParaRPr lang="en-US"/>
+          </a:p>
+        </p:txBody>
       </p:sp>
       <p:sp>
         <p:nvSpPr>
@@ -3372,6 +3950,13 @@
           </p:nvPr>
         </p:nvSpPr>
         <p:spPr/>
+        <p:txBody>
+          <a:bodyPr/>
+          <a:lstStyle/>
+          <a:p>
+            <a:endParaRPr lang="en-US"/>
+          </a:p>
+        </p:txBody>
       </p:sp>
       <p:sp>
         <p:nvSpPr>
@@ -3389,83 +3974,108 @@
           <a:lstStyle/>
           <a:p>
             <a:r>
+              <a:rPr dirty="0"/>
               <a:t>SAY:</a:t>
             </a:r>
           </a:p>
           <a:p>
-            <a:endParaRPr/>
-          </a:p>
-          <a:p>
-            <a:r>
-              <a:t>"These are medians to a complete response, on warm runs with native Ollama on Apple Silicon."</a:t>
-            </a:r>
-          </a:p>
-          <a:p>
-            <a:endParaRPr/>
-          </a:p>
-          <a:p>
-            <a:endParaRPr/>
-          </a:p>
-          <a:p>
-            <a:endParaRPr/>
-          </a:p>
-          <a:p>
-            <a:r>
+            <a:endParaRPr dirty="0"/>
+          </a:p>
+          <a:p>
+            <a:r>
+              <a:rPr dirty="0"/>
+              <a:t>"These are medians to a complete response, on warm runs with native </a:t>
+            </a:r>
+            <a:r>
+              <a:rPr dirty="0" err="1"/>
+              <a:t>Ollama</a:t>
+            </a:r>
+            <a:r>
+              <a:rPr dirty="0"/>
+              <a:t> on Apple Silicon."</a:t>
+            </a:r>
+          </a:p>
+          <a:p>
+            <a:endParaRPr dirty="0"/>
+          </a:p>
+          <a:p>
+            <a:endParaRPr dirty="0"/>
+          </a:p>
+          <a:p>
+            <a:endParaRPr dirty="0"/>
+          </a:p>
+          <a:p>
+            <a:r>
+              <a:rPr dirty="0"/>
               <a:t>1. "REST in 1.11 seconds, GraphQL in 1.26, gRPC in 1.86 including three streamed snapshots."</a:t>
             </a:r>
           </a:p>
           <a:p>
-            <a:endParaRPr/>
-          </a:p>
-          <a:p>
-            <a:r>
+            <a:endParaRPr dirty="0"/>
+          </a:p>
+          <a:p>
+            <a:r>
+              <a:rPr dirty="0"/>
               <a:t>2. "Routing is the cost — about a second on a warm four-billion-parameter model. REST and GraphQL execute in single-digit milliseconds."</a:t>
             </a:r>
           </a:p>
           <a:p>
-            <a:endParaRPr/>
-          </a:p>
-          <a:p>
-            <a:r>
+            <a:endParaRPr dirty="0"/>
+          </a:p>
+          <a:p>
+            <a:r>
+              <a:rPr dirty="0"/>
               <a:t>3. "Most of the gRPC stream time is the deliberate pacing, so you can watch it happen."</a:t>
             </a:r>
           </a:p>
           <a:p>
-            <a:endParaRPr/>
-          </a:p>
-          <a:p>
-            <a:endParaRPr/>
-          </a:p>
-          <a:p>
-            <a:endParaRPr/>
-          </a:p>
-          <a:p>
-            <a:r>
+            <a:endParaRPr dirty="0"/>
+          </a:p>
+          <a:p>
+            <a:endParaRPr dirty="0"/>
+          </a:p>
+          <a:p>
+            <a:endParaRPr dirty="0"/>
+          </a:p>
+          <a:p>
+            <a:r>
+              <a:rPr dirty="0"/>
               <a:t>BE CLEAR ABOUT THIS:</a:t>
             </a:r>
           </a:p>
           <a:p>
-            <a:endParaRPr/>
-          </a:p>
-          <a:p>
-            <a:r>
+            <a:endParaRPr dirty="0"/>
+          </a:p>
+          <a:p>
+            <a:r>
+              <a:rPr dirty="0"/>
               <a:t>"This is a request diagnostic from three runs per protocol, not a load test or a protocol benchmark. You can reproduce it with the benchmark script in the repository."</a:t>
             </a:r>
           </a:p>
           <a:p>
-            <a:endParaRPr/>
-          </a:p>
-          <a:p>
-            <a:r>
+            <a:endParaRPr dirty="0"/>
+          </a:p>
+          <a:p>
+            <a:r>
+              <a:rPr dirty="0"/>
               <a:t>DEMO CONTEXT:</a:t>
             </a:r>
           </a:p>
           <a:p>
-            <a:endParaRPr/>
-          </a:p>
-          <a:p>
-            <a:r>
-              <a:t>These measurements describe the earlier catalog and routing prompt. They are historical context, not a measurement of v4 character and crew routing. Do not promise these timings for the current demo. Rerun scripts/benchmark.mjs in the intended presentation environment for a new baseline.</a:t>
+            <a:endParaRPr dirty="0"/>
+          </a:p>
+          <a:p>
+            <a:r>
+              <a:rPr dirty="0"/>
+              <a:t>These measurements describe the earlier catalog and routing prompt. They are historical context, not a measurement of v4 character and crew routing. Do not promise these timings for the current demo. Rerun scripts/</a:t>
+            </a:r>
+            <a:r>
+              <a:rPr dirty="0" err="1"/>
+              <a:t>benchmark.mjs</a:t>
+            </a:r>
+            <a:r>
+              <a:rPr dirty="0"/>
+              <a:t> in the intended presentation environment for a new baseline.</a:t>
             </a:r>
           </a:p>
         </p:txBody>
@@ -3525,6 +4135,13 @@
           </p:nvPr>
         </p:nvSpPr>
         <p:spPr/>
+        <p:txBody>
+          <a:bodyPr/>
+          <a:lstStyle/>
+          <a:p>
+            <a:endParaRPr lang="en-US"/>
+          </a:p>
+        </p:txBody>
       </p:sp>
       <p:sp>
         <p:nvSpPr>
@@ -3638,6 +4255,13 @@
           </p:nvPr>
         </p:nvSpPr>
         <p:spPr/>
+        <p:txBody>
+          <a:bodyPr/>
+          <a:lstStyle/>
+          <a:p>
+            <a:endParaRPr lang="en-US"/>
+          </a:p>
+        </p:txBody>
       </p:sp>
       <p:sp>
         <p:nvSpPr>
@@ -3783,6 +4407,13 @@
           </p:nvPr>
         </p:nvSpPr>
         <p:spPr/>
+        <p:txBody>
+          <a:bodyPr/>
+          <a:lstStyle/>
+          <a:p>
+            <a:endParaRPr lang="en-US"/>
+          </a:p>
+        </p:txBody>
       </p:sp>
       <p:sp>
         <p:nvSpPr>
@@ -3800,81 +4431,123 @@
           <a:lstStyle/>
           <a:p>
             <a:r>
+              <a:rPr dirty="0"/>
               <a:t>SAY:</a:t>
             </a:r>
-            <a:br/>
-            <a:endParaRPr/>
-          </a:p>
-          <a:p>
-            <a:r>
+            <a:br>
+              <a:rPr dirty="0"/>
+            </a:br>
+            <a:endParaRPr dirty="0"/>
+          </a:p>
+          <a:p>
+            <a:r>
+              <a:rPr dirty="0"/>
               <a:t>"Here are the same questions asked of all three."</a:t>
             </a:r>
-            <a:br/>
-            <a:endParaRPr/>
-          </a:p>
-          <a:p>
-            <a:br/>
-            <a:endParaRPr/>
-          </a:p>
-          <a:p>
-            <a:r>
-              <a:t>1. "Transport and payload: REST and GraphQL are HTTP and JSON. gRPC requires HTTP/2 and uses binary Protobuf."</a:t>
-            </a:r>
-            <a:br/>
-            <a:endParaRPr/>
-          </a:p>
-          <a:p>
-            <a:r>
+            <a:br>
+              <a:rPr dirty="0"/>
+            </a:br>
+            <a:endParaRPr dirty="0"/>
+          </a:p>
+          <a:p>
+            <a:br>
+              <a:rPr dirty="0"/>
+            </a:br>
+            <a:endParaRPr dirty="0"/>
+          </a:p>
+          <a:p>
+            <a:r>
+              <a:rPr dirty="0"/>
+              <a:t>1. "Transport and payload: REST and GraphQL are HTTP and JSON. gRPC requires HTTP/2 and uses binary </a:t>
+            </a:r>
+            <a:r>
+              <a:rPr dirty="0" err="1"/>
+              <a:t>Protobuf</a:t>
+            </a:r>
+            <a:r>
+              <a:rPr dirty="0"/>
+              <a:t>."</a:t>
+            </a:r>
+            <a:br>
+              <a:rPr dirty="0"/>
+            </a:br>
+            <a:endParaRPr dirty="0"/>
+          </a:p>
+          <a:p>
+            <a:r>
+              <a:rPr dirty="0"/>
               <a:t>2. "Contract: optional for REST with OpenAPI, required for GraphQL with its schema, and required for gRPC with the proto file."</a:t>
             </a:r>
-            <a:br/>
-            <a:endParaRPr/>
-          </a:p>
-          <a:p>
-            <a:r>
+            <a:br>
+              <a:rPr dirty="0"/>
+            </a:br>
+            <a:endParaRPr dirty="0"/>
+          </a:p>
+          <a:p>
+            <a:r>
+              <a:rPr dirty="0"/>
               <a:t>3. "Caching is where REST is strongest — it gets HTTP and CDN caching for free. GraphQL and gRPC have to work harder."</a:t>
             </a:r>
-            <a:br/>
-            <a:endParaRPr/>
-          </a:p>
-          <a:p>
-            <a:r>
+            <a:br>
+              <a:rPr dirty="0"/>
+            </a:br>
+            <a:endParaRPr dirty="0"/>
+          </a:p>
+          <a:p>
+            <a:r>
+              <a:rPr dirty="0"/>
               <a:t>4. "Streaming and browser support are where gRPC stands out, in both directions: it streams natively, but browsers need gRPC-Web or a bridge."</a:t>
             </a:r>
-            <a:br/>
-            <a:endParaRPr/>
-          </a:p>
-          <a:p>
-            <a:br/>
-            <a:endParaRPr/>
-          </a:p>
-          <a:p>
-            <a:r>
+            <a:br>
+              <a:rPr dirty="0"/>
+            </a:br>
+            <a:endParaRPr dirty="0"/>
+          </a:p>
+          <a:p>
+            <a:br>
+              <a:rPr dirty="0"/>
+            </a:br>
+            <a:endParaRPr dirty="0"/>
+          </a:p>
+          <a:p>
+            <a:r>
+              <a:rPr dirty="0"/>
               <a:t>BE CLEAR ABOUT THIS:</a:t>
             </a:r>
-            <a:br/>
-            <a:endParaRPr/>
-          </a:p>
-          <a:p>
-            <a:r>
+            <a:br>
+              <a:rPr dirty="0"/>
+            </a:br>
+            <a:endParaRPr dirty="0"/>
+          </a:p>
+          <a:p>
+            <a:r>
+              <a:rPr dirty="0"/>
               <a:t>"Two corrections from last year's version of this table: GraphQL does stream, through subscriptions, and gRPC does not run natively in a browser. Our demo bridges it, and we will show you how."</a:t>
             </a:r>
-            <a:br/>
-            <a:endParaRPr/>
-          </a:p>
-          <a:p>
-            <a:br/>
-            <a:endParaRPr/>
-          </a:p>
-          <a:p>
-            <a:r>
+            <a:br>
+              <a:rPr dirty="0"/>
+            </a:br>
+            <a:endParaRPr dirty="0"/>
+          </a:p>
+          <a:p>
+            <a:br>
+              <a:rPr dirty="0"/>
+            </a:br>
+            <a:endParaRPr dirty="0"/>
+          </a:p>
+          <a:p>
+            <a:r>
+              <a:rPr dirty="0"/>
               <a:t>TRANSITION:</a:t>
             </a:r>
-            <a:br/>
-            <a:endParaRPr/>
-          </a:p>
-          <a:p>
-            <a:r>
+            <a:br>
+              <a:rPr dirty="0"/>
+            </a:br>
+            <a:endParaRPr dirty="0"/>
+          </a:p>
+          <a:p>
+            <a:r>
+              <a:rPr dirty="0"/>
               <a:t>"To make this concrete, here is the data every example uses."</a:t>
             </a:r>
           </a:p>
@@ -3935,6 +4608,13 @@
           </p:nvPr>
         </p:nvSpPr>
         <p:spPr/>
+        <p:txBody>
+          <a:bodyPr/>
+          <a:lstStyle/>
+          <a:p>
+            <a:endParaRPr lang="en-US"/>
+          </a:p>
+        </p:txBody>
       </p:sp>
       <p:sp>
         <p:nvSpPr>
@@ -4109,6 +4789,13 @@
           </p:nvPr>
         </p:nvSpPr>
         <p:spPr/>
+        <p:txBody>
+          <a:bodyPr/>
+          <a:lstStyle/>
+          <a:p>
+            <a:endParaRPr lang="en-US"/>
+          </a:p>
+        </p:txBody>
       </p:sp>
       <p:sp>
         <p:nvSpPr>
@@ -4222,6 +4909,13 @@
           </p:nvPr>
         </p:nvSpPr>
         <p:spPr/>
+        <p:txBody>
+          <a:bodyPr/>
+          <a:lstStyle/>
+          <a:p>
+            <a:endParaRPr lang="en-US"/>
+          </a:p>
+        </p:txBody>
       </p:sp>
       <p:sp>
         <p:nvSpPr>
@@ -4360,6 +5054,13 @@
           </p:nvPr>
         </p:nvSpPr>
         <p:spPr/>
+        <p:txBody>
+          <a:bodyPr/>
+          <a:lstStyle/>
+          <a:p>
+            <a:endParaRPr lang="en-US"/>
+          </a:p>
+        </p:txBody>
       </p:sp>
       <p:sp>
         <p:nvSpPr>
@@ -4966,7 +5667,7 @@
               <a:buNone/>
             </a:pPr>
             <a:r>
-              <a:rPr sz="3600" b="1">
+              <a:rPr sz="3600" b="1" dirty="0">
                 <a:solidFill>
                   <a:srgbClr val="141414"/>
                 </a:solidFill>
@@ -4976,7 +5677,7 @@
               </a:rPr>
               <a:t>REST vs GraphQL vs gRPC</a:t>
             </a:r>
-            <a:endParaRPr sz="3600"/>
+            <a:endParaRPr sz="3600" dirty="0"/>
           </a:p>
         </p:txBody>
       </p:sp>
@@ -5155,10 +5856,10 @@
                 <a:ea typeface="Arial"/>
                 <a:cs typeface="Arial"/>
               </a:rPr>
-              <a:t>A 300-level tour of REST, </a:t>
-            </a:r>
-            <a:r>
-              <a:rPr sz="1300" dirty="0" err="1">
+              <a:t>A</a:t>
+            </a:r>
+            <a:r>
+              <a:rPr lang="en-US" sz="1300" dirty="0">
                 <a:solidFill>
                   <a:srgbClr val="333333"/>
                 </a:solidFill>
@@ -5166,7 +5867,7 @@
                 <a:ea typeface="Arial"/>
                 <a:cs typeface="Arial"/>
               </a:rPr>
-              <a:t>GraphQL</a:t>
+              <a:t>n intermediate</a:t>
             </a:r>
             <a:r>
               <a:rPr sz="1300" dirty="0">
@@ -5177,29 +5878,7 @@
                 <a:ea typeface="Arial"/>
                 <a:cs typeface="Arial"/>
               </a:rPr>
-              <a:t> and </a:t>
-            </a:r>
-            <a:r>
-              <a:rPr sz="1300" dirty="0" err="1">
-                <a:solidFill>
-                  <a:srgbClr val="333333"/>
-                </a:solidFill>
-                <a:latin typeface="Arial"/>
-                <a:ea typeface="Arial"/>
-                <a:cs typeface="Arial"/>
-              </a:rPr>
-              <a:t>gRPC</a:t>
-            </a:r>
-            <a:r>
-              <a:rPr sz="1300" dirty="0">
-                <a:solidFill>
-                  <a:srgbClr val="333333"/>
-                </a:solidFill>
-                <a:latin typeface="Arial"/>
-                <a:ea typeface="Arial"/>
-                <a:cs typeface="Arial"/>
-              </a:rPr>
-              <a:t> through one working app, Protocol Studio: a local or hosted model routes each question to the protocol that fits, and every request is real traffic you can inspect.</a:t>
+              <a:t> 300-level tour of REST, GraphQL and gRPC through one working app, Protocol Studio: a local or hosted model routes each question to the protocol that fits, and every request is real traffic you can inspect.</a:t>
             </a:r>
             <a:endParaRPr sz="1300" dirty="0"/>
           </a:p>
@@ -5240,6 +5919,17 @@
               <a:buNone/>
             </a:pPr>
             <a:r>
+              <a:rPr lang="en-US" sz="1200" dirty="0">
+                <a:solidFill>
+                  <a:srgbClr val="6B6B6B"/>
+                </a:solidFill>
+                <a:latin typeface="Arial"/>
+                <a:ea typeface="Arial"/>
+                <a:cs typeface="Arial"/>
+              </a:rPr>
+              <a:t>dev2next </a:t>
+            </a:r>
+            <a:r>
               <a:rPr sz="1200" dirty="0">
                 <a:solidFill>
                   <a:srgbClr val="6B6B6B"/>
@@ -5248,7 +5938,7 @@
                 <a:ea typeface="Arial"/>
                 <a:cs typeface="Arial"/>
               </a:rPr>
-              <a:t>[Conference name] 2026   •   Insight</a:t>
+              <a:t>2026   •   Insight</a:t>
             </a:r>
             <a:endParaRPr sz="1200" dirty="0"/>
           </a:p>
@@ -5510,7 +6200,7 @@
               <a:buNone/>
             </a:pPr>
             <a:r>
-              <a:rPr sz="1200">
+              <a:rPr sz="1200" dirty="0">
                 <a:solidFill>
                   <a:srgbClr val="FFFFFF"/>
                 </a:solidFill>
@@ -5520,7 +6210,7 @@
               </a:rPr>
               <a:t>REST, GraphQL and gRPC compared on real traffic.</a:t>
             </a:r>
-            <a:endParaRPr sz="1200"/>
+            <a:endParaRPr sz="1200" dirty="0"/>
           </a:p>
         </p:txBody>
       </p:sp>
@@ -5828,7 +6518,7 @@
               <a:buNone/>
             </a:pPr>
             <a:r>
-              <a:rPr sz="1000">
+              <a:rPr sz="1000" dirty="0">
                 <a:solidFill>
                   <a:srgbClr val="6B6B6B"/>
                 </a:solidFill>
@@ -5838,7 +6528,7 @@
               </a:rPr>
               <a:t>Protocol Studio  —  REST · GraphQL · gRPC</a:t>
             </a:r>
-            <a:endParaRPr sz="1000"/>
+            <a:endParaRPr sz="1000" dirty="0"/>
           </a:p>
         </p:txBody>
       </p:sp>
@@ -6872,7 +7562,7 @@
               <a:buNone/>
             </a:pPr>
             <a:r>
-              <a:rPr sz="1000">
+              <a:rPr sz="1000" dirty="0">
                 <a:solidFill>
                   <a:srgbClr val="6B6B6B"/>
                 </a:solidFill>
@@ -6882,7 +7572,7 @@
               </a:rPr>
               <a:t>Protocol Studio  —  REST · GraphQL · gRPC</a:t>
             </a:r>
-            <a:endParaRPr sz="1000"/>
+            <a:endParaRPr sz="1000" dirty="0"/>
           </a:p>
         </p:txBody>
       </p:sp>
@@ -8418,7 +9108,7 @@
               <a:buNone/>
             </a:pPr>
             <a:r>
-              <a:rPr sz="1000">
+              <a:rPr sz="1000" dirty="0">
                 <a:solidFill>
                   <a:srgbClr val="6B6B6B"/>
                 </a:solidFill>
@@ -8428,7 +9118,7 @@
               </a:rPr>
               <a:t>Protocol Studio  —  REST · GraphQL · gRPC</a:t>
             </a:r>
-            <a:endParaRPr sz="1000"/>
+            <a:endParaRPr sz="1000" dirty="0"/>
           </a:p>
         </p:txBody>
       </p:sp>
@@ -8467,7 +9157,7 @@
               <a:buNone/>
             </a:pPr>
             <a:r>
-              <a:rPr sz="1000" b="1">
+              <a:rPr sz="1000" b="1" dirty="0">
                 <a:solidFill>
                   <a:srgbClr val="DA1884"/>
                 </a:solidFill>
@@ -8477,7 +9167,7 @@
               </a:rPr>
               <a:t>GRPC</a:t>
             </a:r>
-            <a:endParaRPr sz="1000"/>
+            <a:endParaRPr sz="1000" dirty="0"/>
           </a:p>
         </p:txBody>
       </p:sp>
@@ -8614,7 +9304,7 @@
               <a:buNone/>
             </a:pPr>
             <a:r>
-              <a:rPr sz="1200" b="1">
+              <a:rPr sz="1200" b="1" dirty="0">
                 <a:solidFill>
                   <a:srgbClr val="DA1884"/>
                 </a:solidFill>
@@ -8624,7 +9314,7 @@
               </a:rPr>
               <a:t>GRPC · HOW IT WORKS</a:t>
             </a:r>
-            <a:endParaRPr sz="1200"/>
+            <a:endParaRPr sz="1200" dirty="0"/>
           </a:p>
         </p:txBody>
       </p:sp>
@@ -8663,7 +9353,7 @@
               <a:buNone/>
             </a:pPr>
             <a:r>
-              <a:rPr sz="3000" b="1">
+              <a:rPr sz="3000" b="1" dirty="0">
                 <a:solidFill>
                   <a:srgbClr val="141414"/>
                 </a:solidFill>
@@ -8673,7 +9363,7 @@
               </a:rPr>
               <a:t>gRPC: Typed Contracts, Streaming by Default</a:t>
             </a:r>
-            <a:endParaRPr sz="3000"/>
+            <a:endParaRPr sz="3000" dirty="0"/>
           </a:p>
         </p:txBody>
       </p:sp>
@@ -8836,7 +9526,7 @@
               <a:buNone/>
             </a:pPr>
             <a:r>
-              <a:rPr sz="1300" b="1">
+              <a:rPr sz="1300" b="1" dirty="0">
                 <a:solidFill>
                   <a:srgbClr val="FFFFFF"/>
                 </a:solidFill>
@@ -8846,7 +9536,7 @@
               </a:rPr>
               <a:t>Where gRPC shines</a:t>
             </a:r>
-            <a:endParaRPr sz="1300"/>
+            <a:endParaRPr sz="1300" dirty="0"/>
           </a:p>
         </p:txBody>
       </p:sp>
@@ -9334,7 +10024,7 @@
               <a:buNone/>
             </a:pPr>
             <a:r>
-              <a:rPr sz="1200" b="1">
+              <a:rPr sz="1200" b="1" dirty="0">
                 <a:solidFill>
                   <a:srgbClr val="141414"/>
                 </a:solidFill>
@@ -9345,7 +10035,7 @@
               <a:t>Use gRPC for  </a:t>
             </a:r>
             <a:r>
-              <a:rPr sz="1200">
+              <a:rPr sz="1200" dirty="0">
                 <a:solidFill>
                   <a:srgbClr val="141414"/>
                 </a:solidFill>
@@ -9355,7 +10045,7 @@
               </a:rPr>
               <a:t>internal service-to-service calls, low-latency paths and real-time streams.</a:t>
             </a:r>
-            <a:endParaRPr sz="1200"/>
+            <a:endParaRPr sz="1200" dirty="0"/>
           </a:p>
         </p:txBody>
       </p:sp>
@@ -9462,7 +10152,7 @@
               <a:buNone/>
             </a:pPr>
             <a:r>
-              <a:rPr sz="1000">
+              <a:rPr sz="1000" dirty="0">
                 <a:solidFill>
                   <a:srgbClr val="6B6B6B"/>
                 </a:solidFill>
@@ -9472,7 +10162,7 @@
               </a:rPr>
               <a:t>Protocol Studio  —  REST · GraphQL · gRPC</a:t>
             </a:r>
-            <a:endParaRPr sz="1000"/>
+            <a:endParaRPr sz="1000" dirty="0"/>
           </a:p>
         </p:txBody>
       </p:sp>
@@ -9511,7 +10201,7 @@
               <a:buNone/>
             </a:pPr>
             <a:r>
-              <a:rPr sz="1000" b="1">
+              <a:rPr sz="1000" b="1" dirty="0">
                 <a:solidFill>
                   <a:srgbClr val="DA1884"/>
                 </a:solidFill>
@@ -9521,7 +10211,7 @@
               </a:rPr>
               <a:t>GRPC</a:t>
             </a:r>
-            <a:endParaRPr sz="1000"/>
+            <a:endParaRPr sz="1000" dirty="0"/>
           </a:p>
         </p:txBody>
       </p:sp>
@@ -9658,7 +10348,7 @@
               <a:buNone/>
             </a:pPr>
             <a:r>
-              <a:rPr sz="1200" b="1">
+              <a:rPr sz="1200" b="1" dirty="0">
                 <a:solidFill>
                   <a:srgbClr val="DA1884"/>
                 </a:solidFill>
@@ -9668,7 +10358,7 @@
               </a:rPr>
               <a:t>GRPC · IN THE DEMO</a:t>
             </a:r>
-            <a:endParaRPr sz="1200"/>
+            <a:endParaRPr sz="1200" dirty="0"/>
           </a:p>
         </p:txBody>
       </p:sp>
@@ -9707,7 +10397,7 @@
               <a:buNone/>
             </a:pPr>
             <a:r>
-              <a:rPr sz="3000" b="1">
+              <a:rPr sz="3000" b="1" dirty="0">
                 <a:solidFill>
                   <a:srgbClr val="141414"/>
                 </a:solidFill>
@@ -9717,7 +10407,7 @@
               </a:rPr>
               <a:t>gRPC in Protocol Studio</a:t>
             </a:r>
-            <a:endParaRPr sz="3000"/>
+            <a:endParaRPr sz="3000" dirty="0"/>
           </a:p>
         </p:txBody>
       </p:sp>
@@ -11002,7 +11692,7 @@
               <a:buNone/>
             </a:pPr>
             <a:r>
-              <a:rPr sz="1000">
+              <a:rPr sz="1000" dirty="0">
                 <a:solidFill>
                   <a:srgbClr val="6B6B6B"/>
                 </a:solidFill>
@@ -11012,7 +11702,7 @@
               </a:rPr>
               <a:t>Protocol Studio  —  REST · GraphQL · gRPC</a:t>
             </a:r>
-            <a:endParaRPr sz="1000"/>
+            <a:endParaRPr sz="1000" dirty="0"/>
           </a:p>
         </p:txBody>
       </p:sp>
@@ -11692,7 +12382,7 @@
               <a:buNone/>
             </a:pPr>
             <a:r>
-              <a:rPr sz="1200">
+              <a:rPr sz="1200" dirty="0">
                 <a:solidFill>
                   <a:srgbClr val="333333"/>
                 </a:solidFill>
@@ -11702,7 +12392,7 @@
               </a:rPr>
               <a:t>GraphQL spec published; gRPC open-sourced by Google</a:t>
             </a:r>
-            <a:endParaRPr sz="1200"/>
+            <a:endParaRPr sz="1200" dirty="0"/>
           </a:p>
         </p:txBody>
       </p:sp>
@@ -11824,7 +12514,7 @@
               <a:buNone/>
             </a:pPr>
             <a:r>
-              <a:rPr sz="1200">
+              <a:rPr sz="1200" dirty="0">
                 <a:solidFill>
                   <a:srgbClr val="333333"/>
                 </a:solidFill>
@@ -11834,7 +12524,7 @@
               </a:rPr>
               <a:t>gRPC 1.0 released; adopted by CNCF in 2017</a:t>
             </a:r>
-            <a:endParaRPr sz="1200"/>
+            <a:endParaRPr sz="1200" dirty="0"/>
           </a:p>
         </p:txBody>
       </p:sp>
@@ -12055,7 +12745,7 @@
                         <a:buNone/>
                       </a:pPr>
                       <a:r>
-                        <a:rPr sz="1200" b="1">
+                        <a:rPr sz="1200" b="1" dirty="0">
                           <a:solidFill>
                             <a:srgbClr val="FFFFFF"/>
                           </a:solidFill>
@@ -12065,7 +12755,7 @@
                         </a:rPr>
                         <a:t>gRPC</a:t>
                       </a:r>
-                      <a:endParaRPr sz="1200">
+                      <a:endParaRPr sz="1200" dirty="0">
                         <a:latin typeface="Arial"/>
                         <a:ea typeface="Arial"/>
                         <a:cs typeface="Arial"/>
@@ -12908,7 +13598,7 @@
               <a:buNone/>
             </a:pPr>
             <a:r>
-              <a:rPr sz="1000">
+              <a:rPr sz="1000" dirty="0">
                 <a:solidFill>
                   <a:srgbClr val="6B6B6B"/>
                 </a:solidFill>
@@ -12918,7 +13608,7 @@
               </a:rPr>
               <a:t>Protocol Studio  —  REST · GraphQL · gRPC</a:t>
             </a:r>
-            <a:endParaRPr sz="1000"/>
+            <a:endParaRPr sz="1000" dirty="0"/>
           </a:p>
         </p:txBody>
       </p:sp>
@@ -13507,7 +14197,7 @@
               <a:buNone/>
             </a:pPr>
             <a:r>
-              <a:rPr sz="1300">
+              <a:rPr sz="1300" dirty="0">
                 <a:solidFill>
                   <a:srgbClr val="333333"/>
                 </a:solidFill>
@@ -13517,7 +14207,7 @@
               </a:rPr>
               <a:t>Global retail coffee: gRPC at the edge</a:t>
             </a:r>
-            <a:endParaRPr sz="1300"/>
+            <a:endParaRPr sz="1300" dirty="0"/>
           </a:p>
         </p:txBody>
       </p:sp>
@@ -13629,7 +14319,7 @@
               <a:buNone/>
             </a:pPr>
             <a:r>
-              <a:rPr sz="1000">
+              <a:rPr sz="1000" dirty="0">
                 <a:solidFill>
                   <a:srgbClr val="6B6B6B"/>
                 </a:solidFill>
@@ -13639,7 +14329,7 @@
               </a:rPr>
               <a:t>Protocol Studio  —  REST · GraphQL · gRPC</a:t>
             </a:r>
-            <a:endParaRPr sz="1000"/>
+            <a:endParaRPr sz="1000" dirty="0"/>
           </a:p>
         </p:txBody>
       </p:sp>
@@ -14390,7 +15080,7 @@
               <a:buNone/>
             </a:pPr>
             <a:r>
-              <a:rPr sz="1200" b="1">
+              <a:rPr sz="1200" b="1" dirty="0">
                 <a:solidFill>
                   <a:srgbClr val="DA1884"/>
                 </a:solidFill>
@@ -14400,7 +15090,7 @@
               </a:rPr>
               <a:t>GRPC · STREAMING</a:t>
             </a:r>
-            <a:endParaRPr sz="1200"/>
+            <a:endParaRPr sz="1200" dirty="0"/>
           </a:p>
           <a:p>
             <a:pPr marL="0" indent="0">
@@ -14413,7 +15103,7 @@
               <a:buNone/>
             </a:pPr>
             <a:r>
-              <a:rPr sz="1500" b="1">
+              <a:rPr sz="1500" b="1" dirty="0">
                 <a:solidFill>
                   <a:srgbClr val="141414"/>
                 </a:solidFill>
@@ -14423,7 +15113,7 @@
               </a:rPr>
               <a:t>“Track the Millennium Falcon.”</a:t>
             </a:r>
-            <a:endParaRPr sz="1200"/>
+            <a:endParaRPr sz="1200" dirty="0"/>
           </a:p>
           <a:p>
             <a:pPr marL="0" indent="0">
@@ -14433,7 +15123,7 @@
               <a:buNone/>
             </a:pPr>
             <a:r>
-              <a:rPr sz="1200">
+              <a:rPr sz="1200" dirty="0">
                 <a:solidFill>
                   <a:srgbClr val="333333"/>
                 </a:solidFill>
@@ -14443,7 +15133,7 @@
               </a:rPr>
               <a:t>One Watch subscription streams a 40-second simulated flight into an updating chat card.</a:t>
             </a:r>
-            <a:endParaRPr sz="1200"/>
+            <a:endParaRPr sz="1200" dirty="0"/>
           </a:p>
         </p:txBody>
       </p:sp>
@@ -14796,10 +15486,10 @@
                 <a:ea typeface="Arial"/>
                 <a:cs typeface="Arial"/>
               </a:rPr>
-              <a:t>Java 25 · Spring Boot 4.1 · Spring for </a:t>
-            </a:r>
-            <a:r>
-              <a:rPr sz="1200" dirty="0" err="1">
+              <a:t>Java 25 · Spring Boot 4.1 · Spring for GraphQL · </a:t>
+            </a:r>
+            <a:r>
+              <a:rPr lang="en-US" sz="1200" dirty="0">
                 <a:solidFill>
                   <a:srgbClr val="333333"/>
                 </a:solidFill>
@@ -14807,40 +15497,7 @@
                 <a:ea typeface="Arial"/>
                 <a:cs typeface="Arial"/>
               </a:rPr>
-              <a:t>GraphQL</a:t>
-            </a:r>
-            <a:r>
-              <a:rPr sz="1200" dirty="0">
-                <a:solidFill>
-                  <a:srgbClr val="333333"/>
-                </a:solidFill>
-                <a:latin typeface="Arial"/>
-                <a:ea typeface="Arial"/>
-                <a:cs typeface="Arial"/>
-              </a:rPr>
-              <a:t> · </a:t>
-            </a:r>
-            <a:r>
-              <a:rPr lang="en-US" sz="1200" dirty="0">
-                <a:solidFill>
-                  <a:srgbClr val="333333"/>
-                </a:solidFill>
-                <a:latin typeface="Arial"/>
-                <a:ea typeface="Arial"/>
-                <a:cs typeface="Arial"/>
-              </a:rPr>
-              <a:t>Spring for </a:t>
-            </a:r>
-            <a:r>
-              <a:rPr lang="en-US" sz="1200" dirty="0" err="1">
-                <a:solidFill>
-                  <a:srgbClr val="333333"/>
-                </a:solidFill>
-                <a:latin typeface="Arial"/>
-                <a:ea typeface="Arial"/>
-                <a:cs typeface="Arial"/>
-              </a:rPr>
-              <a:t>gRPC</a:t>
+              <a:t>Spring for gRPC</a:t>
             </a:r>
             <a:endParaRPr sz="1200" dirty="0"/>
           </a:p>
@@ -15007,7 +15664,7 @@
               <a:buNone/>
             </a:pPr>
             <a:r>
-              <a:rPr sz="1000">
+              <a:rPr sz="1000" dirty="0">
                 <a:solidFill>
                   <a:srgbClr val="6B6B6B"/>
                 </a:solidFill>
@@ -15017,7 +15674,7 @@
               </a:rPr>
               <a:t>Protocol Studio  —  REST · GraphQL · gRPC</a:t>
             </a:r>
-            <a:endParaRPr sz="1000"/>
+            <a:endParaRPr sz="1000" dirty="0"/>
           </a:p>
         </p:txBody>
       </p:sp>
@@ -16061,7 +16718,7 @@
               <a:buNone/>
             </a:pPr>
             <a:r>
-              <a:rPr sz="1000">
+              <a:rPr sz="1000" dirty="0">
                 <a:solidFill>
                   <a:srgbClr val="6B6B6B"/>
                 </a:solidFill>
@@ -16071,7 +16728,7 @@
               </a:rPr>
               <a:t>Protocol Studio  —  REST · GraphQL · gRPC</a:t>
             </a:r>
-            <a:endParaRPr sz="1000"/>
+            <a:endParaRPr sz="1000" dirty="0"/>
           </a:p>
         </p:txBody>
       </p:sp>
@@ -16920,7 +17577,7 @@
               <a:buNone/>
             </a:pPr>
             <a:r>
-              <a:rPr sz="1300" b="1">
+              <a:rPr sz="1300" b="1" dirty="0">
                 <a:solidFill>
                   <a:srgbClr val="FFFFFF"/>
                 </a:solidFill>
@@ -16930,7 +17587,7 @@
               </a:rPr>
               <a:t>Why gRPC</a:t>
             </a:r>
-            <a:endParaRPr sz="1300"/>
+            <a:endParaRPr sz="1300" dirty="0"/>
           </a:p>
         </p:txBody>
       </p:sp>
@@ -17021,7 +17678,7 @@
               <a:buChar char="•"/>
             </a:pPr>
             <a:r>
-              <a:rPr sz="1200" dirty="0" err="1">
+              <a:rPr sz="1200" dirty="0">
                 <a:solidFill>
                   <a:srgbClr val="333333"/>
                 </a:solidFill>
@@ -17029,18 +17686,7 @@
                 <a:ea typeface="Arial"/>
                 <a:cs typeface="Arial"/>
               </a:rPr>
-              <a:t>gRPC</a:t>
-            </a:r>
-            <a:r>
-              <a:rPr sz="1200" dirty="0">
-                <a:solidFill>
-                  <a:srgbClr val="333333"/>
-                </a:solidFill>
-                <a:latin typeface="Arial"/>
-                <a:ea typeface="Arial"/>
-                <a:cs typeface="Arial"/>
-              </a:rPr>
-              <a:t> integration reduces exposure and increases performance</a:t>
+              <a:t>gRPC integration reduces exposure and increases performance</a:t>
             </a:r>
             <a:endParaRPr sz="1200" dirty="0"/>
           </a:p>
@@ -17064,29 +17710,7 @@
                 <a:ea typeface="Arial"/>
                 <a:cs typeface="Arial"/>
               </a:rPr>
-              <a:t>Service-based integration built on typed </a:t>
-            </a:r>
-            <a:r>
-              <a:rPr sz="1200" dirty="0" err="1">
-                <a:solidFill>
-                  <a:srgbClr val="333333"/>
-                </a:solidFill>
-                <a:latin typeface="Arial"/>
-                <a:ea typeface="Arial"/>
-                <a:cs typeface="Arial"/>
-              </a:rPr>
-              <a:t>gRPC</a:t>
-            </a:r>
-            <a:r>
-              <a:rPr sz="1200" dirty="0">
-                <a:solidFill>
-                  <a:srgbClr val="333333"/>
-                </a:solidFill>
-                <a:latin typeface="Arial"/>
-                <a:ea typeface="Arial"/>
-                <a:cs typeface="Arial"/>
-              </a:rPr>
-              <a:t> contracts</a:t>
+              <a:t>Service-based integration built on typed gRPC contracts</a:t>
             </a:r>
             <a:endParaRPr sz="1200" dirty="0"/>
           </a:p>
@@ -17195,7 +17819,7 @@
               <a:buNone/>
             </a:pPr>
             <a:r>
-              <a:rPr sz="1000">
+              <a:rPr sz="1000" dirty="0">
                 <a:solidFill>
                   <a:srgbClr val="6B6B6B"/>
                 </a:solidFill>
@@ -17205,7 +17829,7 @@
               </a:rPr>
               <a:t>Protocol Studio  —  REST · GraphQL · gRPC</a:t>
             </a:r>
-            <a:endParaRPr sz="1000"/>
+            <a:endParaRPr sz="1000" dirty="0"/>
           </a:p>
         </p:txBody>
       </p:sp>
@@ -17616,7 +18240,7 @@
               <a:buNone/>
             </a:pPr>
             <a:r>
-              <a:rPr sz="1200" b="1">
+              <a:rPr sz="1200" b="1" dirty="0">
                 <a:solidFill>
                   <a:srgbClr val="DA1884"/>
                 </a:solidFill>
@@ -17626,7 +18250,7 @@
               </a:rPr>
               <a:t>01</a:t>
             </a:r>
-            <a:endParaRPr sz="1200"/>
+            <a:endParaRPr sz="1200" dirty="0"/>
           </a:p>
           <a:p>
             <a:pPr marL="0" indent="0">
@@ -17639,7 +18263,7 @@
               <a:buNone/>
             </a:pPr>
             <a:r>
-              <a:rPr sz="1500" b="1">
+              <a:rPr sz="1500" b="1" dirty="0">
                 <a:solidFill>
                   <a:srgbClr val="141414"/>
                 </a:solidFill>
@@ -17649,7 +18273,7 @@
               </a:rPr>
               <a:t>Choose per operation</a:t>
             </a:r>
-            <a:endParaRPr sz="1200"/>
+            <a:endParaRPr sz="1200" dirty="0"/>
           </a:p>
           <a:p>
             <a:pPr marL="0" indent="0">
@@ -17659,7 +18283,7 @@
               <a:buNone/>
             </a:pPr>
             <a:r>
-              <a:rPr sz="1200">
+              <a:rPr sz="1200" dirty="0">
                 <a:solidFill>
                   <a:srgbClr val="333333"/>
                 </a:solidFill>
@@ -17669,7 +18293,7 @@
               </a:rPr>
               <a:t>REST for cacheable resources, GraphQL for related data, and gRPC for streams and service-to-service calls. Most systems use more than one.</a:t>
             </a:r>
-            <a:endParaRPr sz="1200"/>
+            <a:endParaRPr sz="1200" dirty="0"/>
           </a:p>
         </p:txBody>
       </p:sp>
@@ -18255,7 +18879,7 @@
               <a:buNone/>
             </a:pPr>
             <a:r>
-              <a:rPr sz="1000">
+              <a:rPr sz="1000" dirty="0">
                 <a:solidFill>
                   <a:srgbClr val="6B6B6B"/>
                 </a:solidFill>
@@ -18265,7 +18889,7 @@
               </a:rPr>
               <a:t>Protocol Studio  —  REST · GraphQL · gRPC</a:t>
             </a:r>
-            <a:endParaRPr sz="1000"/>
+            <a:endParaRPr sz="1000" dirty="0"/>
           </a:p>
         </p:txBody>
       </p:sp>
@@ -18549,7 +19173,7 @@
               <a:buNone/>
             </a:pPr>
             <a:r>
-              <a:rPr sz="1400">
+              <a:rPr sz="1400" dirty="0">
                 <a:solidFill>
                   <a:srgbClr val="6B6B6B"/>
                 </a:solidFill>
@@ -18559,7 +19183,7 @@
               </a:rPr>
               <a:t>Three sections, one running application. Every example is real HTTP, GraphQL and gRPC traffic, with no mocks.</a:t>
             </a:r>
-            <a:endParaRPr sz="1400"/>
+            <a:endParaRPr sz="1400" dirty="0"/>
           </a:p>
         </p:txBody>
       </p:sp>
@@ -19042,7 +19666,7 @@
               <a:buNone/>
             </a:pPr>
             <a:r>
-              <a:rPr sz="1200">
+              <a:rPr sz="1200" dirty="0">
                 <a:solidFill>
                   <a:srgbClr val="333333"/>
                 </a:solidFill>
@@ -19052,7 +19676,7 @@
               </a:rPr>
               <a:t>REST, GraphQL and gRPC, each covered twice: first the concept, then the working code.</a:t>
             </a:r>
-            <a:endParaRPr sz="1200"/>
+            <a:endParaRPr sz="1200" dirty="0"/>
           </a:p>
         </p:txBody>
       </p:sp>
@@ -19642,141 +20266,6 @@
                 <a:cs typeface="Arial"/>
               </a:rPr>
               <a:t>Time permitting</a:t>
-            </a:r>
-            <a:endParaRPr sz="1200"/>
-          </a:p>
-        </p:txBody>
-      </p:sp>
-      <p:sp>
-        <p:nvSpPr>
-          <p:cNvPr id="35" name="Shape 31">
-            <a:extLst>
-              <a:ext uri="{FF2B5EF4-FFF2-40B4-BE49-F238E27FC236}">
-                <a16:creationId xmlns:a16="http://schemas.microsoft.com/office/drawing/2014/main" id="{1B2C37F4-99CB-44ED-9E15-4D530806C085}"/>
-              </a:ext>
-            </a:extLst>
-          </p:cNvPr>
-          <p:cNvSpPr>
-            <a:spLocks noGrp="1"/>
-          </p:cNvSpPr>
-          <p:nvPr/>
-        </p:nvSpPr>
-        <p:spPr>
-          <a:xfrm>
-            <a:off x="508000" y="5588000"/>
-            <a:ext cx="11176000" cy="609600"/>
-          </a:xfrm>
-          <a:prstGeom prst="rect">
-            <a:avLst/>
-          </a:prstGeom>
-          <a:solidFill>
-            <a:srgbClr val="F4F4F4"/>
-          </a:solidFill>
-          <a:effectLst>
-            <a:outerShdw blurRad="50800" dist="25400" dir="5400000" algn="bl" rotWithShape="0">
-              <a:srgbClr val="000000">
-                <a:alpha val="18000"/>
-              </a:srgbClr>
-            </a:outerShdw>
-          </a:effectLst>
-        </p:spPr>
-        <p:txBody>
-          <a:bodyPr/>
-          <a:lstStyle/>
-          <a:p>
-            <a:endParaRPr/>
-          </a:p>
-        </p:txBody>
-      </p:sp>
-      <p:sp>
-        <p:nvSpPr>
-          <p:cNvPr id="36" name="Shape 32">
-            <a:extLst>
-              <a:ext uri="{FF2B5EF4-FFF2-40B4-BE49-F238E27FC236}">
-                <a16:creationId xmlns:a16="http://schemas.microsoft.com/office/drawing/2014/main" id="{D01887B4-2BB6-483D-90AA-9313A15ECDA1}"/>
-              </a:ext>
-            </a:extLst>
-          </p:cNvPr>
-          <p:cNvSpPr>
-            <a:spLocks noGrp="1"/>
-          </p:cNvSpPr>
-          <p:nvPr/>
-        </p:nvSpPr>
-        <p:spPr>
-          <a:xfrm>
-            <a:off x="508000" y="5588000"/>
-            <a:ext cx="76200" cy="609600"/>
-          </a:xfrm>
-          <a:prstGeom prst="rect">
-            <a:avLst/>
-          </a:prstGeom>
-          <a:solidFill>
-            <a:srgbClr val="DA1884"/>
-          </a:solidFill>
-        </p:spPr>
-        <p:txBody>
-          <a:bodyPr/>
-          <a:lstStyle/>
-          <a:p>
-            <a:endParaRPr/>
-          </a:p>
-        </p:txBody>
-      </p:sp>
-      <p:sp>
-        <p:nvSpPr>
-          <p:cNvPr id="37" name="Text 33">
-            <a:extLst>
-              <a:ext uri="{FF2B5EF4-FFF2-40B4-BE49-F238E27FC236}">
-                <a16:creationId xmlns:a16="http://schemas.microsoft.com/office/drawing/2014/main" id="{EF6BCF56-F7D4-4E80-A1F0-177490680375}"/>
-              </a:ext>
-            </a:extLst>
-          </p:cNvPr>
-          <p:cNvSpPr>
-            <a:spLocks noGrp="1"/>
-          </p:cNvSpPr>
-          <p:nvPr/>
-        </p:nvSpPr>
-        <p:spPr>
-          <a:xfrm>
-            <a:off x="787400" y="5588000"/>
-            <a:ext cx="10668000" cy="609600"/>
-          </a:xfrm>
-          <a:prstGeom prst="rect">
-            <a:avLst/>
-          </a:prstGeom>
-          <a:noFill/>
-        </p:spPr>
-        <p:txBody>
-          <a:bodyPr wrap="square" lIns="0" tIns="0" rIns="0" bIns="0" anchor="ctr"/>
-          <a:lstStyle/>
-          <a:p>
-            <a:pPr marL="0" indent="0">
-              <a:lnSpc>
-                <a:spcPct val="115000"/>
-              </a:lnSpc>
-              <a:buNone/>
-            </a:pPr>
-            <a:r>
-              <a:rPr sz="1200" b="1">
-                <a:solidFill>
-                  <a:srgbClr val="141414"/>
-                </a:solidFill>
-                <a:latin typeface="Arial"/>
-                <a:ea typeface="Arial"/>
-                <a:cs typeface="Arial"/>
-              </a:rPr>
-              <a:t>300-level.  </a:t>
-            </a:r>
-            <a:r>
-              <a:rPr sz="1200">
-                <a:solidFill>
-                  <a:srgbClr val="141414"/>
-                </a:solidFill>
-                <a:latin typeface="Arial"/>
-                <a:ea typeface="Arial"/>
-                <a:cs typeface="Arial"/>
-              </a:rPr>
-              <a:t>We assume you have built an API before. The focus is trade-offs you can apply on Monday.</a:t>
             </a:r>
             <a:endParaRPr sz="1200"/>
           </a:p>
@@ -20685,7 +21174,7 @@
               <a:buNone/>
             </a:pPr>
             <a:r>
-              <a:rPr sz="1000">
+              <a:rPr sz="1000" dirty="0">
                 <a:solidFill>
                   <a:srgbClr val="6B6B6B"/>
                 </a:solidFill>
@@ -20695,7 +21184,7 @@
               </a:rPr>
               <a:t>Protocol Studio  —  REST · GraphQL · gRPC</a:t>
             </a:r>
-            <a:endParaRPr sz="1000"/>
+            <a:endParaRPr sz="1000" dirty="0"/>
           </a:p>
         </p:txBody>
       </p:sp>
@@ -21450,7 +21939,7 @@
               <a:buNone/>
             </a:pPr>
             <a:r>
-              <a:rPr sz="1000">
+              <a:rPr sz="1000" dirty="0">
                 <a:solidFill>
                   <a:srgbClr val="6B6B6B"/>
                 </a:solidFill>
@@ -21460,7 +21949,7 @@
               </a:rPr>
               <a:t>Protocol Studio  —  REST · GraphQL · gRPC</a:t>
             </a:r>
-            <a:endParaRPr sz="1000"/>
+            <a:endParaRPr sz="1000" dirty="0"/>
           </a:p>
         </p:txBody>
       </p:sp>
@@ -22483,7 +22972,7 @@
               <a:buNone/>
             </a:pPr>
             <a:r>
-              <a:rPr sz="1200" b="1">
+              <a:rPr sz="1200" b="1" dirty="0">
                 <a:solidFill>
                   <a:srgbClr val="DA1884"/>
                 </a:solidFill>
@@ -22493,7 +22982,7 @@
               </a:rPr>
               <a:t>04 · EXECUTE</a:t>
             </a:r>
-            <a:endParaRPr sz="1200"/>
+            <a:endParaRPr sz="1200" dirty="0"/>
           </a:p>
           <a:p>
             <a:pPr marL="0" indent="0">
@@ -22506,7 +22995,7 @@
               <a:buNone/>
             </a:pPr>
             <a:r>
-              <a:rPr sz="1300" b="1">
+              <a:rPr sz="1300" b="1" dirty="0">
                 <a:solidFill>
                   <a:srgbClr val="141414"/>
                 </a:solidFill>
@@ -22516,7 +23005,7 @@
               </a:rPr>
               <a:t>Real transport</a:t>
             </a:r>
-            <a:endParaRPr sz="1200"/>
+            <a:endParaRPr sz="1200" dirty="0"/>
           </a:p>
           <a:p>
             <a:pPr marL="0" indent="0">
@@ -22526,7 +23015,7 @@
               <a:buNone/>
             </a:pPr>
             <a:r>
-              <a:rPr sz="1200">
+              <a:rPr sz="1200" dirty="0">
                 <a:solidFill>
                   <a:srgbClr val="333333"/>
                 </a:solidFill>
@@ -22536,7 +23025,7 @@
               </a:rPr>
               <a:t>Calls its own REST, GraphQL or native gRPC endpoint.</a:t>
             </a:r>
-            <a:endParaRPr sz="1200"/>
+            <a:endParaRPr sz="1200" dirty="0"/>
           </a:p>
         </p:txBody>
       </p:sp>
@@ -22982,7 +23471,7 @@
               <a:buNone/>
             </a:pPr>
             <a:r>
-              <a:rPr sz="1000">
+              <a:rPr sz="1000" dirty="0">
                 <a:solidFill>
                   <a:srgbClr val="6B6B6B"/>
                 </a:solidFill>
@@ -22992,7 +23481,7 @@
               </a:rPr>
               <a:t>Protocol Studio  —  REST · GraphQL · gRPC</a:t>
             </a:r>
-            <a:endParaRPr sz="1000"/>
+            <a:endParaRPr sz="1000" dirty="0"/>
           </a:p>
         </p:txBody>
       </p:sp>
@@ -23845,7 +24334,7 @@
               <a:buNone/>
             </a:pPr>
             <a:r>
-              <a:rPr sz="1300" b="1">
+              <a:rPr sz="1300" b="1" dirty="0">
                 <a:solidFill>
                   <a:srgbClr val="141414"/>
                 </a:solidFill>
@@ -23855,7 +24344,7 @@
               </a:rPr>
               <a:t>The tool name is the decision</a:t>
             </a:r>
-            <a:endParaRPr sz="1300"/>
+            <a:endParaRPr sz="1300" dirty="0"/>
           </a:p>
           <a:p>
             <a:pPr marL="0" indent="0">
@@ -23865,7 +24354,7 @@
               <a:buNone/>
             </a:pPr>
             <a:r>
-              <a:rPr sz="1200">
+              <a:rPr sz="1200" dirty="0">
                 <a:solidFill>
                   <a:srgbClr val="333333"/>
                 </a:solidFill>
@@ -23875,7 +24364,7 @@
               </a:rPr>
               <a:t>REST, GRAPHQL or GRPC: the model must call exactly one.</a:t>
             </a:r>
-            <a:endParaRPr sz="1300"/>
+            <a:endParaRPr sz="1300" dirty="0"/>
           </a:p>
         </p:txBody>
       </p:sp>
@@ -24570,7 +25059,7 @@
               <a:buNone/>
             </a:pPr>
             <a:r>
-              <a:rPr sz="1000">
+              <a:rPr sz="1000" dirty="0">
                 <a:solidFill>
                   <a:srgbClr val="6B6B6B"/>
                 </a:solidFill>
@@ -24580,7 +25069,7 @@
               </a:rPr>
               <a:t>Protocol Studio  —  REST · GraphQL · gRPC</a:t>
             </a:r>
-            <a:endParaRPr sz="1000"/>
+            <a:endParaRPr sz="1000" dirty="0"/>
           </a:p>
         </p:txBody>
       </p:sp>
@@ -25037,7 +25526,7 @@
               <a:buNone/>
             </a:pPr>
             <a:r>
-              <a:rPr sz="1200">
+              <a:rPr sz="1200" dirty="0">
                 <a:solidFill>
                   <a:srgbClr val="EDEDED"/>
                 </a:solidFill>
@@ -25047,7 +25536,7 @@
               </a:rPr>
               <a:t>{</a:t>
             </a:r>
-            <a:endParaRPr sz="1200"/>
+            <a:endParaRPr sz="1200" dirty="0"/>
           </a:p>
           <a:p>
             <a:pPr marL="0" indent="0">
@@ -25057,7 +25546,7 @@
               <a:buNone/>
             </a:pPr>
             <a:r>
-              <a:rPr sz="1200">
+              <a:rPr sz="1200" dirty="0">
                 <a:solidFill>
                   <a:srgbClr val="EDEDED"/>
                 </a:solidFill>
@@ -25065,19 +25554,10 @@
                 <a:ea typeface="Consolas"/>
                 <a:cs typeface="Consolas"/>
               </a:rPr>
-              <a:t>  "model": "jev-latest",</a:t>
-            </a:r>
-            <a:endParaRPr sz="1200"/>
-          </a:p>
-          <a:p>
-            <a:pPr marL="0" indent="0">
-              <a:lnSpc>
-                <a:spcPct val="120000"/>
-              </a:lnSpc>
-              <a:buNone/>
-            </a:pPr>
-            <a:r>
-              <a:rPr sz="1200">
+              <a:t>  "model": "</a:t>
+            </a:r>
+            <a:r>
+              <a:rPr sz="1200" dirty="0" err="1">
                 <a:solidFill>
                   <a:srgbClr val="EDEDED"/>
                 </a:solidFill>
@@ -25085,19 +25565,10 @@
                 <a:ea typeface="Consolas"/>
                 <a:cs typeface="Consolas"/>
               </a:rPr>
-              <a:t>  "state": { "message": "…",</a:t>
-            </a:r>
-            <a:endParaRPr sz="1200"/>
-          </a:p>
-          <a:p>
-            <a:pPr marL="0" indent="0">
-              <a:lnSpc>
-                <a:spcPct val="120000"/>
-              </a:lnSpc>
-              <a:buNone/>
-            </a:pPr>
-            <a:r>
-              <a:rPr sz="1200">
+              <a:t>jev</a:t>
+            </a:r>
+            <a:r>
+              <a:rPr sz="1200" dirty="0">
                 <a:solidFill>
                   <a:srgbClr val="EDEDED"/>
                 </a:solidFill>
@@ -25105,9 +25576,9 @@
                 <a:ea typeface="Consolas"/>
                 <a:cs typeface="Consolas"/>
               </a:rPr>
-              <a:t>             "history": [ … ] },</a:t>
-            </a:r>
-            <a:endParaRPr sz="1200"/>
+              <a:t>-latest",</a:t>
+            </a:r>
+            <a:endParaRPr sz="1200" dirty="0"/>
           </a:p>
           <a:p>
             <a:pPr marL="0" indent="0">
@@ -25117,7 +25588,7 @@
               <a:buNone/>
             </a:pPr>
             <a:r>
-              <a:rPr sz="1200">
+              <a:rPr sz="1200" dirty="0">
                 <a:solidFill>
                   <a:srgbClr val="EDEDED"/>
                 </a:solidFill>
@@ -25125,9 +25596,9 @@
                 <a:ea typeface="Consolas"/>
                 <a:cs typeface="Consolas"/>
               </a:rPr>
-              <a:t>  "questions": {</a:t>
-            </a:r>
-            <a:endParaRPr sz="1200"/>
+              <a:t>  "state": { "message": "…",</a:t>
+            </a:r>
+            <a:endParaRPr sz="1200" dirty="0"/>
           </a:p>
           <a:p>
             <a:pPr marL="0" indent="0">
@@ -25137,7 +25608,7 @@
               <a:buNone/>
             </a:pPr>
             <a:r>
-              <a:rPr sz="1200">
+              <a:rPr sz="1200" dirty="0">
                 <a:solidFill>
                   <a:srgbClr val="EDEDED"/>
                 </a:solidFill>
@@ -25145,9 +25616,9 @@
                 <a:ea typeface="Consolas"/>
                 <a:cs typeface="Consolas"/>
               </a:rPr>
-              <a:t>    "protocol": { "type": "choice",</a:t>
-            </a:r>
-            <a:endParaRPr sz="1200"/>
+              <a:t>             "history": [ … ] },</a:t>
+            </a:r>
+            <a:endParaRPr sz="1200" dirty="0"/>
           </a:p>
           <a:p>
             <a:pPr marL="0" indent="0">
@@ -25157,7 +25628,7 @@
               <a:buNone/>
             </a:pPr>
             <a:r>
-              <a:rPr sz="1200">
+              <a:rPr sz="1200" dirty="0">
                 <a:solidFill>
                   <a:srgbClr val="EDEDED"/>
                 </a:solidFill>
@@ -25165,9 +25636,9 @@
                 <a:ea typeface="Consolas"/>
                 <a:cs typeface="Consolas"/>
               </a:rPr>
-              <a:t>      "criteria": { "REST": "…",</a:t>
-            </a:r>
-            <a:endParaRPr sz="1200"/>
+              <a:t>  "questions": {</a:t>
+            </a:r>
+            <a:endParaRPr sz="1200" dirty="0"/>
           </a:p>
           <a:p>
             <a:pPr marL="0" indent="0">
@@ -25177,7 +25648,7 @@
               <a:buNone/>
             </a:pPr>
             <a:r>
-              <a:rPr sz="1200">
+              <a:rPr sz="1200" dirty="0">
                 <a:solidFill>
                   <a:srgbClr val="EDEDED"/>
                 </a:solidFill>
@@ -25185,9 +25656,9 @@
                 <a:ea typeface="Consolas"/>
                 <a:cs typeface="Consolas"/>
               </a:rPr>
-              <a:t>        "GRAPHQL": "…", "GRPC": "…" } },</a:t>
-            </a:r>
-            <a:endParaRPr sz="1200"/>
+              <a:t>    "protocol": { "type": "choice",</a:t>
+            </a:r>
+            <a:endParaRPr sz="1200" dirty="0"/>
           </a:p>
           <a:p>
             <a:pPr marL="0" indent="0">
@@ -25197,7 +25668,7 @@
               <a:buNone/>
             </a:pPr>
             <a:r>
-              <a:rPr sz="1200">
+              <a:rPr sz="1200" dirty="0">
                 <a:solidFill>
                   <a:srgbClr val="EDEDED"/>
                 </a:solidFill>
@@ -25205,9 +25676,9 @@
                 <a:ea typeface="Consolas"/>
                 <a:cs typeface="Consolas"/>
               </a:rPr>
-              <a:t>    "target": { "type": "choice",</a:t>
-            </a:r>
-            <a:endParaRPr sz="1200"/>
+              <a:t>      "criteria": { "REST": "…",</a:t>
+            </a:r>
+            <a:endParaRPr sz="1200" dirty="0"/>
           </a:p>
           <a:p>
             <a:pPr marL="0" indent="0">
@@ -25217,7 +25688,7 @@
               <a:buNone/>
             </a:pPr>
             <a:r>
-              <a:rPr sz="1200">
+              <a:rPr sz="1200" dirty="0">
                 <a:solidFill>
                   <a:srgbClr val="EDEDED"/>
                 </a:solidFill>
@@ -25225,9 +25696,9 @@
                 <a:ea typeface="Consolas"/>
                 <a:cs typeface="Consolas"/>
               </a:rPr>
-              <a:t>      "criteria": { "ship:5": "…" } }</a:t>
-            </a:r>
-            <a:endParaRPr sz="1200"/>
+              <a:t>        "GRAPHQL": "…", "GRPC": "…" } },</a:t>
+            </a:r>
+            <a:endParaRPr sz="1200" dirty="0"/>
           </a:p>
           <a:p>
             <a:pPr marL="0" indent="0">
@@ -25237,7 +25708,7 @@
               <a:buNone/>
             </a:pPr>
             <a:r>
-              <a:rPr sz="1200">
+              <a:rPr sz="1200" dirty="0">
                 <a:solidFill>
                   <a:srgbClr val="EDEDED"/>
                 </a:solidFill>
@@ -25245,9 +25716,9 @@
                 <a:ea typeface="Consolas"/>
                 <a:cs typeface="Consolas"/>
               </a:rPr>
-              <a:t>  }</a:t>
-            </a:r>
-            <a:endParaRPr sz="1200"/>
+              <a:t>    "target": { "type": "choice",</a:t>
+            </a:r>
+            <a:endParaRPr sz="1200" dirty="0"/>
           </a:p>
           <a:p>
             <a:pPr marL="0" indent="0">
@@ -25257,7 +25728,7 @@
               <a:buNone/>
             </a:pPr>
             <a:r>
-              <a:rPr sz="1200">
+              <a:rPr sz="1200" dirty="0">
                 <a:solidFill>
                   <a:srgbClr val="EDEDED"/>
                 </a:solidFill>
@@ -25265,9 +25736,49 @@
                 <a:ea typeface="Consolas"/>
                 <a:cs typeface="Consolas"/>
               </a:rPr>
+              <a:t>      "criteria": { "ship:5": "…" } }</a:t>
+            </a:r>
+            <a:endParaRPr sz="1200" dirty="0"/>
+          </a:p>
+          <a:p>
+            <a:pPr marL="0" indent="0">
+              <a:lnSpc>
+                <a:spcPct val="120000"/>
+              </a:lnSpc>
+              <a:buNone/>
+            </a:pPr>
+            <a:r>
+              <a:rPr sz="1200" dirty="0">
+                <a:solidFill>
+                  <a:srgbClr val="EDEDED"/>
+                </a:solidFill>
+                <a:latin typeface="Consolas"/>
+                <a:ea typeface="Consolas"/>
+                <a:cs typeface="Consolas"/>
+              </a:rPr>
+              <a:t>  }</a:t>
+            </a:r>
+            <a:endParaRPr sz="1200" dirty="0"/>
+          </a:p>
+          <a:p>
+            <a:pPr marL="0" indent="0">
+              <a:lnSpc>
+                <a:spcPct val="120000"/>
+              </a:lnSpc>
+              <a:buNone/>
+            </a:pPr>
+            <a:r>
+              <a:rPr sz="1200" dirty="0">
+                <a:solidFill>
+                  <a:srgbClr val="EDEDED"/>
+                </a:solidFill>
+                <a:latin typeface="Consolas"/>
+                <a:ea typeface="Consolas"/>
+                <a:cs typeface="Consolas"/>
+              </a:rPr>
               <a:t>}</a:t>
             </a:r>
-            <a:endParaRPr sz="1200"/>
+            <a:endParaRPr sz="1200" dirty="0"/>
           </a:p>
         </p:txBody>
       </p:sp>
@@ -25962,7 +26473,7 @@
               <a:buNone/>
             </a:pPr>
             <a:r>
-              <a:rPr sz="1000">
+              <a:rPr sz="1000" dirty="0">
                 <a:solidFill>
                   <a:srgbClr val="6B6B6B"/>
                 </a:solidFill>
@@ -25972,7 +26483,7 @@
               </a:rPr>
               <a:t>Protocol Studio  —  REST · GraphQL · gRPC</a:t>
             </a:r>
-            <a:endParaRPr sz="1000"/>
+            <a:endParaRPr sz="1000" dirty="0"/>
           </a:p>
         </p:txBody>
       </p:sp>
@@ -27769,7 +28280,7 @@
               <a:buNone/>
             </a:pPr>
             <a:r>
-              <a:rPr sz="1000">
+              <a:rPr sz="1000" dirty="0">
                 <a:solidFill>
                   <a:srgbClr val="6B6B6B"/>
                 </a:solidFill>
@@ -27779,7 +28290,7 @@
               </a:rPr>
               <a:t>Protocol Studio  —  REST · GraphQL · gRPC</a:t>
             </a:r>
-            <a:endParaRPr sz="1000"/>
+            <a:endParaRPr sz="1000" dirty="0"/>
           </a:p>
         </p:txBody>
       </p:sp>
@@ -29535,7 +30046,7 @@
               <a:buNone/>
             </a:pPr>
             <a:r>
-              <a:rPr sz="1000">
+              <a:rPr sz="1000" dirty="0">
                 <a:solidFill>
                   <a:srgbClr val="6B6B6B"/>
                 </a:solidFill>
@@ -29545,7 +30056,7 @@
               </a:rPr>
               <a:t>Protocol Studio  —  REST · GraphQL · gRPC</a:t>
             </a:r>
-            <a:endParaRPr sz="1000"/>
+            <a:endParaRPr sz="1000" dirty="0"/>
           </a:p>
         </p:txBody>
       </p:sp>
@@ -30397,7 +30908,7 @@
               <a:buNone/>
             </a:pPr>
             <a:r>
-              <a:rPr sz="1200" b="1">
+              <a:rPr sz="1200" b="1" dirty="0">
                 <a:solidFill>
                   <a:srgbClr val="DA1884"/>
                 </a:solidFill>
@@ -30407,7 +30918,7 @@
               </a:rPr>
               <a:t>GRPC</a:t>
             </a:r>
-            <a:endParaRPr sz="1200"/>
+            <a:endParaRPr sz="1200" dirty="0"/>
           </a:p>
         </p:txBody>
       </p:sp>
@@ -30944,7 +31455,7 @@
               <a:buNone/>
             </a:pPr>
             <a:r>
-              <a:rPr sz="1200" b="1">
+              <a:rPr sz="1200" b="1" dirty="0">
                 <a:solidFill>
                   <a:srgbClr val="141414"/>
                 </a:solidFill>
@@ -30954,7 +31465,7 @@
               </a:rPr>
               <a:t>gRPC</a:t>
             </a:r>
-            <a:endParaRPr sz="1200"/>
+            <a:endParaRPr sz="1200" dirty="0"/>
           </a:p>
         </p:txBody>
       </p:sp>
@@ -31227,7 +31738,7 @@
               <a:buNone/>
             </a:pPr>
             <a:r>
-              <a:rPr sz="1000">
+              <a:rPr sz="1000" dirty="0">
                 <a:solidFill>
                   <a:srgbClr val="6B6B6B"/>
                 </a:solidFill>
@@ -31237,7 +31748,7 @@
               </a:rPr>
               <a:t>Protocol Studio  —  REST · GraphQL · gRPC</a:t>
             </a:r>
-            <a:endParaRPr sz="1000"/>
+            <a:endParaRPr sz="1000" dirty="0"/>
           </a:p>
         </p:txBody>
       </p:sp>
@@ -31943,7 +32454,7 @@
               <a:buNone/>
             </a:pPr>
             <a:r>
-              <a:rPr sz="1000">
+              <a:rPr sz="1000" dirty="0">
                 <a:solidFill>
                   <a:srgbClr val="6B6B6B"/>
                 </a:solidFill>
@@ -31953,7 +32464,7 @@
               </a:rPr>
               <a:t>Protocol Studio  —  REST · GraphQL · gRPC</a:t>
             </a:r>
-            <a:endParaRPr sz="1000"/>
+            <a:endParaRPr sz="1000" dirty="0"/>
           </a:p>
         </p:txBody>
       </p:sp>
@@ -32999,7 +33510,7 @@
               <a:buNone/>
             </a:pPr>
             <a:r>
-              <a:rPr sz="1000">
+              <a:rPr sz="1000" dirty="0">
                 <a:solidFill>
                   <a:srgbClr val="6B6B6B"/>
                 </a:solidFill>
@@ -33009,7 +33520,7 @@
               </a:rPr>
               <a:t>Protocol Studio  —  REST · GraphQL · gRPC</a:t>
             </a:r>
-            <a:endParaRPr sz="1000"/>
+            <a:endParaRPr sz="1000" dirty="0"/>
           </a:p>
         </p:txBody>
       </p:sp>
@@ -33535,7 +34046,7 @@
                         <a:buNone/>
                       </a:pPr>
                       <a:r>
-                        <a:rPr sz="1200" b="1">
+                        <a:rPr sz="1200" b="1" dirty="0">
                           <a:solidFill>
                             <a:srgbClr val="FFFFFF"/>
                           </a:solidFill>
@@ -33545,7 +34056,7 @@
                         </a:rPr>
                         <a:t>gRPC</a:t>
                       </a:r>
-                      <a:endParaRPr sz="1200">
+                      <a:endParaRPr sz="1200" dirty="0">
                         <a:latin typeface="Arial"/>
                         <a:ea typeface="Arial"/>
                         <a:cs typeface="Arial"/>
@@ -35543,7 +36054,7 @@
               <a:buNone/>
             </a:pPr>
             <a:r>
-              <a:rPr sz="1000">
+              <a:rPr sz="1000" dirty="0">
                 <a:solidFill>
                   <a:srgbClr val="6B6B6B"/>
                 </a:solidFill>
@@ -35553,7 +36064,7 @@
               </a:rPr>
               <a:t>Protocol Studio  —  REST · GraphQL · gRPC</a:t>
             </a:r>
-            <a:endParaRPr sz="1000"/>
+            <a:endParaRPr sz="1000" dirty="0"/>
           </a:p>
         </p:txBody>
       </p:sp>
@@ -36861,7 +37372,7 @@
               <a:buNone/>
             </a:pPr>
             <a:r>
-              <a:rPr sz="1200" b="1">
+              <a:rPr sz="1200" b="1" dirty="0">
                 <a:solidFill>
                   <a:srgbClr val="141414"/>
                 </a:solidFill>
@@ -36872,7 +37383,7 @@
               <a:t>One immutable, in-memory catalog.  </a:t>
             </a:r>
             <a:r>
-              <a:rPr sz="1200">
+              <a:rPr sz="1200" dirty="0">
                 <a:solidFill>
                   <a:srgbClr val="141414"/>
                 </a:solidFill>
@@ -36882,7 +37393,7 @@
               </a:rPr>
               <a:t>REST, GraphQL and gRPC all read the same seeded source. There is no database to configure, and all three protocols see identical data.</a:t>
             </a:r>
-            <a:endParaRPr sz="1200"/>
+            <a:endParaRPr sz="1200" dirty="0"/>
           </a:p>
         </p:txBody>
       </p:sp>
@@ -36989,7 +37500,7 @@
               <a:buNone/>
             </a:pPr>
             <a:r>
-              <a:rPr sz="1000">
+              <a:rPr sz="1000" dirty="0">
                 <a:solidFill>
                   <a:srgbClr val="6B6B6B"/>
                 </a:solidFill>
@@ -36999,7 +37510,7 @@
               </a:rPr>
               <a:t>Protocol Studio  —  REST · GraphQL · gRPC</a:t>
             </a:r>
-            <a:endParaRPr sz="1000"/>
+            <a:endParaRPr sz="1000" dirty="0"/>
           </a:p>
         </p:txBody>
       </p:sp>
@@ -37317,7 +37828,7 @@
               <a:buNone/>
             </a:pPr>
             <a:r>
-              <a:rPr sz="1500">
+              <a:rPr sz="1500" dirty="0">
                 <a:solidFill>
                   <a:srgbClr val="6B6B6B"/>
                 </a:solidFill>
@@ -37327,7 +37838,7 @@
               </a:rPr>
               <a:t>REST, GraphQL and gRPC: each in concept, then in working code.</a:t>
             </a:r>
-            <a:endParaRPr sz="1500"/>
+            <a:endParaRPr sz="1500" dirty="0"/>
           </a:p>
         </p:txBody>
       </p:sp>
@@ -37588,7 +38099,7 @@
               <a:buNone/>
             </a:pPr>
             <a:r>
-              <a:rPr sz="1300">
+              <a:rPr sz="1300" dirty="0">
                 <a:solidFill>
                   <a:srgbClr val="333333"/>
                 </a:solidFill>
@@ -37598,7 +38109,7 @@
               </a:rPr>
               <a:t>gRPC: typed contracts and streaming over HTTP/2</a:t>
             </a:r>
-            <a:endParaRPr sz="1300"/>
+            <a:endParaRPr sz="1300" dirty="0"/>
           </a:p>
         </p:txBody>
       </p:sp>
@@ -37754,7 +38265,7 @@
               <a:buNone/>
             </a:pPr>
             <a:r>
-              <a:rPr sz="1000">
+              <a:rPr sz="1000" dirty="0">
                 <a:solidFill>
                   <a:srgbClr val="6B6B6B"/>
                 </a:solidFill>
@@ -37764,7 +38275,7 @@
               </a:rPr>
               <a:t>Protocol Studio  —  REST · GraphQL · gRPC</a:t>
             </a:r>
-            <a:endParaRPr sz="1000"/>
+            <a:endParaRPr sz="1000" dirty="0"/>
           </a:p>
         </p:txBody>
       </p:sp>
@@ -38798,7 +39309,7 @@
               <a:buNone/>
             </a:pPr>
             <a:r>
-              <a:rPr sz="1000">
+              <a:rPr sz="1000" dirty="0">
                 <a:solidFill>
                   <a:srgbClr val="6B6B6B"/>
                 </a:solidFill>
@@ -38808,7 +39319,7 @@
               </a:rPr>
               <a:t>Protocol Studio  —  REST · GraphQL · gRPC</a:t>
             </a:r>
-            <a:endParaRPr sz="1000"/>
+            <a:endParaRPr sz="1000" dirty="0"/>
           </a:p>
         </p:txBody>
       </p:sp>

</xml_diff>